<commit_message>
Document transfer learning: README, docs and a pitch-deck slide
Adds the measured results (cross-validation, few-shot curve, held-out set)
with their caveats, a file map, and a transfer-learning slide in the pitch
deck. Slides after it are renumbered.

Co-Authored-By: Claude Sonnet 5.5 <noreply@anthropic.com>
</commit_message>
<xml_diff>
--- a/VYBE_Learn_Pitch_Deck.pptx
+++ b/VYBE_Learn_Pitch_Deck.pptx
@@ -15,6 +15,7 @@
     <p:sldId id="263" r:id="rId14"/>
     <p:sldId id="264" r:id="rId15"/>
     <p:sldId id="265" r:id="rId16"/>
+    <p:sldId id="266" r:id="rId17"/>
   </p:sldIdLst>
   <p:sldSz cx="12191695" cy="6858000" type="screen4x3"/>
   <p:notesSz cx="6858000" cy="9144000"/>
@@ -3931,7 +3932,986 @@
                 </a:solidFill>
                 <a:latin typeface="Consolas"/>
               </a:rPr>
-              <a:t>08 — FOR THE DECK</a:t>
+              <a:t>08 — THE CASE</a:t>
+            </a:r>
+          </a:p>
+        </p:txBody>
+      </p:sp>
+      <p:sp>
+        <p:nvSpPr>
+          <p:cNvPr id="3" name="TextBox 2"/>
+          <p:cNvSpPr txBox="1"/>
+          <p:nvPr/>
+        </p:nvSpPr>
+        <p:spPr>
+          <a:xfrm>
+            <a:off x="640080" y="777240"/>
+            <a:ext cx="10881360" cy="1005840"/>
+          </a:xfrm>
+          <a:prstGeom prst="rect">
+            <a:avLst/>
+          </a:prstGeom>
+          <a:noFill/>
+        </p:spPr>
+        <p:txBody>
+          <a:bodyPr wrap="square">
+            <a:spAutoFit/>
+          </a:bodyPr>
+          <a:lstStyle/>
+          <a:p>
+            <a:pPr algn="l">
+              <a:spcAft>
+                <a:spcPts val="600"/>
+              </a:spcAft>
+            </a:pPr>
+            <a:r>
+              <a:rPr sz="3200" b="1" i="0">
+                <a:solidFill>
+                  <a:srgbClr val="F4F2F7"/>
+                </a:solidFill>
+                <a:latin typeface="Georgia"/>
+              </a:rPr>
+              <a:t>Why this beats a chatbot wrapper</a:t>
+            </a:r>
+          </a:p>
+        </p:txBody>
+      </p:sp>
+      <p:graphicFrame>
+        <p:nvGraphicFramePr>
+          <p:cNvPr id="4" name="Table 3"/>
+          <p:cNvGraphicFramePr>
+            <a:graphicFrameLocks noGrp="1"/>
+          </p:cNvGraphicFramePr>
+          <p:nvPr/>
+        </p:nvGraphicFramePr>
+        <p:xfrm>
+          <a:off x="640080" y="1463040"/>
+          <a:ext cx="10881360" cy="3291840"/>
+        </p:xfrm>
+        <a:graphic>
+          <a:graphicData uri="http://schemas.openxmlformats.org/drawingml/2006/table">
+            <a:tbl>
+              <a:tblPr firstRow="1" bandRow="1">
+                <a:tableStyleId>{5C22544A-7EE6-4342-B048-85BDC9FD1C3A}</a:tableStyleId>
+              </a:tblPr>
+              <a:tblGrid>
+                <a:gridCol w="2834640"/>
+                <a:gridCol w="4023360"/>
+                <a:gridCol w="4023360"/>
+              </a:tblGrid>
+              <a:tr h="470262">
+                <a:tc>
+                  <a:txBody>
+                    <a:bodyPr wrap="square"/>
+                    <a:lstStyle/>
+                    <a:p>
+                      <a:r>
+                        <a:rPr sz="1000" b="1" i="0">
+                          <a:solidFill>
+                            <a:srgbClr val="635D6E"/>
+                          </a:solidFill>
+                          <a:latin typeface="Consolas"/>
+                        </a:rPr>
+                        <a:t>Axis</a:t>
+                      </a:r>
+                    </a:p>
+                  </a:txBody>
+                  <a:tcPr marL="109728" anchor="ctr">
+                    <a:solidFill>
+                      <a:srgbClr val="1D1A25"/>
+                    </a:solidFill>
+                  </a:tcPr>
+                </a:tc>
+                <a:tc>
+                  <a:txBody>
+                    <a:bodyPr wrap="square"/>
+                    <a:lstStyle/>
+                    <a:p>
+                      <a:r>
+                        <a:rPr sz="1000" b="1" i="0">
+                          <a:solidFill>
+                            <a:srgbClr val="635D6E"/>
+                          </a:solidFill>
+                          <a:latin typeface="Consolas"/>
+                        </a:rPr>
+                        <a:t>Typical AI-tutor demo</a:t>
+                      </a:r>
+                    </a:p>
+                  </a:txBody>
+                  <a:tcPr marL="109728" anchor="ctr">
+                    <a:solidFill>
+                      <a:srgbClr val="1D1A25"/>
+                    </a:solidFill>
+                  </a:tcPr>
+                </a:tc>
+                <a:tc>
+                  <a:txBody>
+                    <a:bodyPr wrap="square"/>
+                    <a:lstStyle/>
+                    <a:p>
+                      <a:r>
+                        <a:rPr sz="1000" b="1" i="0">
+                          <a:solidFill>
+                            <a:srgbClr val="635D6E"/>
+                          </a:solidFill>
+                          <a:latin typeface="Consolas"/>
+                        </a:rPr>
+                        <a:t>VYBE Learn</a:t>
+                      </a:r>
+                    </a:p>
+                  </a:txBody>
+                  <a:tcPr marL="109728" anchor="ctr">
+                    <a:solidFill>
+                      <a:srgbClr val="1D1A25"/>
+                    </a:solidFill>
+                  </a:tcPr>
+                </a:tc>
+              </a:tr>
+              <a:tr h="470262">
+                <a:tc>
+                  <a:txBody>
+                    <a:bodyPr wrap="square"/>
+                    <a:lstStyle/>
+                    <a:p>
+                      <a:r>
+                        <a:rPr sz="1100" b="0" i="0">
+                          <a:solidFill>
+                            <a:srgbClr val="F4F2F7"/>
+                          </a:solidFill>
+                          <a:latin typeface="Calibri"/>
+                        </a:rPr>
+                        <a:t>Who decides the fix</a:t>
+                      </a:r>
+                    </a:p>
+                  </a:txBody>
+                  <a:tcPr marL="109728" anchor="ctr">
+                    <a:solidFill>
+                      <a:srgbClr val="16141C"/>
+                    </a:solidFill>
+                  </a:tcPr>
+                </a:tc>
+                <a:tc>
+                  <a:txBody>
+                    <a:bodyPr wrap="square"/>
+                    <a:lstStyle/>
+                    <a:p>
+                      <a:r>
+                        <a:rPr sz="1100" b="0" i="0">
+                          <a:solidFill>
+                            <a:srgbClr val="FF6B7A"/>
+                          </a:solidFill>
+                          <a:latin typeface="Calibri"/>
+                        </a:rPr>
+                        <a:t>✗  the LLM guesses in-context</a:t>
+                      </a:r>
+                    </a:p>
+                  </a:txBody>
+                  <a:tcPr marL="109728" anchor="ctr">
+                    <a:solidFill>
+                      <a:srgbClr val="16141C"/>
+                    </a:solidFill>
+                  </a:tcPr>
+                </a:tc>
+                <a:tc>
+                  <a:txBody>
+                    <a:bodyPr wrap="square"/>
+                    <a:lstStyle/>
+                    <a:p>
+                      <a:r>
+                        <a:rPr sz="1100" b="0" i="0">
+                          <a:solidFill>
+                            <a:srgbClr val="3DDC8A"/>
+                          </a:solidFill>
+                          <a:latin typeface="Calibri"/>
+                        </a:rPr>
+                        <a:t>✓  a deterministic loop, measured and re-checked</a:t>
+                      </a:r>
+                    </a:p>
+                  </a:txBody>
+                  <a:tcPr marL="109728" anchor="ctr">
+                    <a:solidFill>
+                      <a:srgbClr val="16141C"/>
+                    </a:solidFill>
+                  </a:tcPr>
+                </a:tc>
+              </a:tr>
+              <a:tr h="470262">
+                <a:tc>
+                  <a:txBody>
+                    <a:bodyPr wrap="square"/>
+                    <a:lstStyle/>
+                    <a:p>
+                      <a:r>
+                        <a:rPr sz="1100" b="0" i="0">
+                          <a:solidFill>
+                            <a:srgbClr val="F4F2F7"/>
+                          </a:solidFill>
+                          <a:latin typeface="Calibri"/>
+                        </a:rPr>
+                        <a:t>Why a fix was kept</a:t>
+                      </a:r>
+                    </a:p>
+                  </a:txBody>
+                  <a:tcPr marL="109728" anchor="ctr">
+                    <a:solidFill>
+                      <a:srgbClr val="16141C"/>
+                    </a:solidFill>
+                  </a:tcPr>
+                </a:tc>
+                <a:tc>
+                  <a:txBody>
+                    <a:bodyPr wrap="square"/>
+                    <a:lstStyle/>
+                    <a:p>
+                      <a:r>
+                        <a:rPr sz="1100" b="0" i="0">
+                          <a:solidFill>
+                            <a:srgbClr val="FF6B7A"/>
+                          </a:solidFill>
+                          <a:latin typeface="Calibri"/>
+                        </a:rPr>
+                        <a:t>✗  a plausible-sounding sentence</a:t>
+                      </a:r>
+                    </a:p>
+                  </a:txBody>
+                  <a:tcPr marL="109728" anchor="ctr">
+                    <a:solidFill>
+                      <a:srgbClr val="16141C"/>
+                    </a:solidFill>
+                  </a:tcPr>
+                </a:tc>
+                <a:tc>
+                  <a:txBody>
+                    <a:bodyPr wrap="square"/>
+                    <a:lstStyle/>
+                    <a:p>
+                      <a:r>
+                        <a:rPr sz="1100" b="0" i="0">
+                          <a:solidFill>
+                            <a:srgbClr val="3DDC8A"/>
+                          </a:solidFill>
+                          <a:latin typeface="Calibri"/>
+                        </a:rPr>
+                        <a:t>✓  a real skew-shift number against a stated threshold</a:t>
+                      </a:r>
+                    </a:p>
+                  </a:txBody>
+                  <a:tcPr marL="109728" anchor="ctr">
+                    <a:solidFill>
+                      <a:srgbClr val="16141C"/>
+                    </a:solidFill>
+                  </a:tcPr>
+                </a:tc>
+              </a:tr>
+              <a:tr h="470262">
+                <a:tc>
+                  <a:txBody>
+                    <a:bodyPr wrap="square"/>
+                    <a:lstStyle/>
+                    <a:p>
+                      <a:r>
+                        <a:rPr sz="1100" b="0" i="0">
+                          <a:solidFill>
+                            <a:srgbClr val="F4F2F7"/>
+                          </a:solidFill>
+                          <a:latin typeface="Calibri"/>
+                        </a:rPr>
+                        <a:t>When the model breaks</a:t>
+                      </a:r>
+                    </a:p>
+                  </a:txBody>
+                  <a:tcPr marL="109728" anchor="ctr">
+                    <a:solidFill>
+                      <a:srgbClr val="16141C"/>
+                    </a:solidFill>
+                  </a:tcPr>
+                </a:tc>
+                <a:tc>
+                  <a:txBody>
+                    <a:bodyPr wrap="square"/>
+                    <a:lstStyle/>
+                    <a:p>
+                      <a:r>
+                        <a:rPr sz="1100" b="0" i="0">
+                          <a:solidFill>
+                            <a:srgbClr val="FF6B7A"/>
+                          </a:solidFill>
+                          <a:latin typeface="Calibri"/>
+                        </a:rPr>
+                        <a:t>✗  stalls, apologizes, or hallucinates</a:t>
+                      </a:r>
+                    </a:p>
+                  </a:txBody>
+                  <a:tcPr marL="109728" anchor="ctr">
+                    <a:solidFill>
+                      <a:srgbClr val="16141C"/>
+                    </a:solidFill>
+                  </a:tcPr>
+                </a:tc>
+                <a:tc>
+                  <a:txBody>
+                    <a:bodyPr wrap="square"/>
+                    <a:lstStyle/>
+                    <a:p>
+                      <a:r>
+                        <a:rPr sz="1100" b="0" i="0">
+                          <a:solidFill>
+                            <a:srgbClr val="3DDC8A"/>
+                          </a:solidFill>
+                          <a:latin typeface="Calibri"/>
+                        </a:rPr>
+                        <a:t>✓  falls through ADK → Gemini → FAQ, discloses which</a:t>
+                      </a:r>
+                    </a:p>
+                  </a:txBody>
+                  <a:tcPr marL="109728" anchor="ctr">
+                    <a:solidFill>
+                      <a:srgbClr val="16141C"/>
+                    </a:solidFill>
+                  </a:tcPr>
+                </a:tc>
+              </a:tr>
+              <a:tr h="470262">
+                <a:tc>
+                  <a:txBody>
+                    <a:bodyPr wrap="square"/>
+                    <a:lstStyle/>
+                    <a:p>
+                      <a:r>
+                        <a:rPr sz="1100" b="0" i="0">
+                          <a:solidFill>
+                            <a:srgbClr val="F4F2F7"/>
+                          </a:solidFill>
+                          <a:latin typeface="Calibri"/>
+                        </a:rPr>
+                        <a:t>Personalization</a:t>
+                      </a:r>
+                    </a:p>
+                  </a:txBody>
+                  <a:tcPr marL="109728" anchor="ctr">
+                    <a:solidFill>
+                      <a:srgbClr val="16141C"/>
+                    </a:solidFill>
+                  </a:tcPr>
+                </a:tc>
+                <a:tc>
+                  <a:txBody>
+                    <a:bodyPr wrap="square"/>
+                    <a:lstStyle/>
+                    <a:p>
+                      <a:r>
+                        <a:rPr sz="1100" b="0" i="0">
+                          <a:solidFill>
+                            <a:srgbClr val="FF6B7A"/>
+                          </a:solidFill>
+                          <a:latin typeface="Calibri"/>
+                        </a:rPr>
+                        <a:t>✗  one-size tone knob</a:t>
+                      </a:r>
+                    </a:p>
+                  </a:txBody>
+                  <a:tcPr marL="109728" anchor="ctr">
+                    <a:solidFill>
+                      <a:srgbClr val="16141C"/>
+                    </a:solidFill>
+                  </a:tcPr>
+                </a:tc>
+                <a:tc>
+                  <a:txBody>
+                    <a:bodyPr wrap="square"/>
+                    <a:lstStyle/>
+                    <a:p>
+                      <a:r>
+                        <a:rPr sz="1100" b="0" i="0">
+                          <a:solidFill>
+                            <a:srgbClr val="3DDC8A"/>
+                          </a:solidFill>
+                          <a:latin typeface="Calibri"/>
+                        </a:rPr>
+                        <a:t>✓  3 modes, driven by real hint/attempt counters</a:t>
+                      </a:r>
+                    </a:p>
+                  </a:txBody>
+                  <a:tcPr marL="109728" anchor="ctr">
+                    <a:solidFill>
+                      <a:srgbClr val="16141C"/>
+                    </a:solidFill>
+                  </a:tcPr>
+                </a:tc>
+              </a:tr>
+              <a:tr h="470262">
+                <a:tc>
+                  <a:txBody>
+                    <a:bodyPr wrap="square"/>
+                    <a:lstStyle/>
+                    <a:p>
+                      <a:r>
+                        <a:rPr sz="1100" b="0" i="0">
+                          <a:solidFill>
+                            <a:srgbClr val="F4F2F7"/>
+                          </a:solidFill>
+                          <a:latin typeface="Calibri"/>
+                        </a:rPr>
+                        <a:t>Cheats the learner?</a:t>
+                      </a:r>
+                    </a:p>
+                  </a:txBody>
+                  <a:tcPr marL="109728" anchor="ctr">
+                    <a:solidFill>
+                      <a:srgbClr val="16141C"/>
+                    </a:solidFill>
+                  </a:tcPr>
+                </a:tc>
+                <a:tc>
+                  <a:txBody>
+                    <a:bodyPr wrap="square"/>
+                    <a:lstStyle/>
+                    <a:p>
+                      <a:r>
+                        <a:rPr sz="1100" b="0" i="0">
+                          <a:solidFill>
+                            <a:srgbClr val="FF6B7A"/>
+                          </a:solidFill>
+                          <a:latin typeface="Calibri"/>
+                        </a:rPr>
+                        <a:t>✗  answers before they've tried</a:t>
+                      </a:r>
+                    </a:p>
+                  </a:txBody>
+                  <a:tcPr marL="109728" anchor="ctr">
+                    <a:solidFill>
+                      <a:srgbClr val="16141C"/>
+                    </a:solidFill>
+                  </a:tcPr>
+                </a:tc>
+                <a:tc>
+                  <a:txBody>
+                    <a:bodyPr wrap="square"/>
+                    <a:lstStyle/>
+                    <a:p>
+                      <a:r>
+                        <a:rPr sz="1100" b="0" i="0">
+                          <a:solidFill>
+                            <a:srgbClr val="3DDC8A"/>
+                          </a:solidFill>
+                          <a:latin typeface="Calibri"/>
+                        </a:rPr>
+                        <a:t>✓  nudges only, reveal gated on attempt history</a:t>
+                      </a:r>
+                    </a:p>
+                  </a:txBody>
+                  <a:tcPr marL="109728" anchor="ctr">
+                    <a:solidFill>
+                      <a:srgbClr val="16141C"/>
+                    </a:solidFill>
+                  </a:tcPr>
+                </a:tc>
+              </a:tr>
+              <a:tr h="470268">
+                <a:tc>
+                  <a:txBody>
+                    <a:bodyPr wrap="square"/>
+                    <a:lstStyle/>
+                    <a:p>
+                      <a:r>
+                        <a:rPr sz="1100" b="0" i="0">
+                          <a:solidFill>
+                            <a:srgbClr val="F4F2F7"/>
+                          </a:solidFill>
+                          <a:latin typeface="Calibri"/>
+                        </a:rPr>
+                        <a:t>Respects prior knowledge</a:t>
+                      </a:r>
+                    </a:p>
+                  </a:txBody>
+                  <a:tcPr marL="109728" anchor="ctr">
+                    <a:solidFill>
+                      <a:srgbClr val="16141C"/>
+                    </a:solidFill>
+                  </a:tcPr>
+                </a:tc>
+                <a:tc>
+                  <a:txBody>
+                    <a:bodyPr wrap="square"/>
+                    <a:lstStyle/>
+                    <a:p>
+                      <a:r>
+                        <a:rPr sz="1100" b="0" i="0">
+                          <a:solidFill>
+                            <a:srgbClr val="FF6B7A"/>
+                          </a:solidFill>
+                          <a:latin typeface="Calibri"/>
+                        </a:rPr>
+                        <a:t>✗  forces every learner through every step</a:t>
+                      </a:r>
+                    </a:p>
+                  </a:txBody>
+                  <a:tcPr marL="109728" anchor="ctr">
+                    <a:solidFill>
+                      <a:srgbClr val="16141C"/>
+                    </a:solidFill>
+                  </a:tcPr>
+                </a:tc>
+                <a:tc>
+                  <a:txBody>
+                    <a:bodyPr wrap="square"/>
+                    <a:lstStyle/>
+                    <a:p>
+                      <a:r>
+                        <a:rPr sz="1100" b="0" i="0">
+                          <a:solidFill>
+                            <a:srgbClr val="3DDC8A"/>
+                          </a:solidFill>
+                          <a:latin typeface="Calibri"/>
+                        </a:rPr>
+                        <a:t>✓  explicit Skip actions, no faked checkmarks</a:t>
+                      </a:r>
+                    </a:p>
+                  </a:txBody>
+                  <a:tcPr marL="109728" anchor="ctr">
+                    <a:solidFill>
+                      <a:srgbClr val="16141C"/>
+                    </a:solidFill>
+                  </a:tcPr>
+                </a:tc>
+              </a:tr>
+            </a:tbl>
+          </a:graphicData>
+        </a:graphic>
+      </p:graphicFrame>
+      <p:sp>
+        <p:nvSpPr>
+          <p:cNvPr id="5" name="Rounded Rectangle 4"/>
+          <p:cNvSpPr/>
+          <p:nvPr/>
+        </p:nvSpPr>
+        <p:spPr>
+          <a:xfrm>
+            <a:off x="640080" y="4983480"/>
+            <a:ext cx="2615184" cy="1325880"/>
+          </a:xfrm>
+          <a:prstGeom prst="roundRect">
+            <a:avLst>
+              <a:gd name="adj" fmla="val 6000"/>
+            </a:avLst>
+          </a:prstGeom>
+          <a:solidFill>
+            <a:srgbClr val="16141C"/>
+          </a:solidFill>
+          <a:ln w="12700">
+            <a:solidFill>
+              <a:srgbClr val="28242F"/>
+            </a:solidFill>
+          </a:ln>
+          <a:effectLst/>
+        </p:spPr>
+        <p:style>
+          <a:lnRef idx="1">
+            <a:schemeClr val="accent1"/>
+          </a:lnRef>
+          <a:fillRef idx="3">
+            <a:schemeClr val="accent1"/>
+          </a:fillRef>
+          <a:effectRef idx="2">
+            <a:schemeClr val="accent1"/>
+          </a:effectRef>
+          <a:fontRef idx="minor">
+            <a:schemeClr val="lt1"/>
+          </a:fontRef>
+        </p:style>
+        <p:txBody>
+          <a:bodyPr rtlCol="0" anchor="ctr" wrap="square" lIns="137160" tIns="91440"/>
+          <a:lstStyle/>
+          <a:p>
+            <a:pPr algn="l">
+              <a:spcAft>
+                <a:spcPts val="300"/>
+              </a:spcAft>
+            </a:pPr>
+            <a:r>
+              <a:rPr sz="1600" b="1" i="0">
+                <a:solidFill>
+                  <a:srgbClr val="FF3EA5"/>
+                </a:solidFill>
+                <a:latin typeface="Consolas"/>
+              </a:rPr>
+              <a:t>01</a:t>
+            </a:r>
+          </a:p>
+          <a:p>
+            <a:pPr algn="l">
+              <a:spcAft>
+                <a:spcPts val="300"/>
+              </a:spcAft>
+            </a:pPr>
+            <a:r>
+              <a:rPr sz="1200" b="1" i="0">
+                <a:solidFill>
+                  <a:srgbClr val="F4F2F7"/>
+                </a:solidFill>
+                <a:latin typeface="Georgia"/>
+              </a:rPr>
+              <a:t>Technical depth</a:t>
+            </a:r>
+          </a:p>
+          <a:p>
+            <a:pPr algn="l">
+              <a:spcAft>
+                <a:spcPts val="0"/>
+              </a:spcAft>
+            </a:pPr>
+            <a:r>
+              <a:rPr sz="950" b="0" i="0">
+                <a:solidFill>
+                  <a:srgbClr val="948FA0"/>
+                </a:solidFill>
+                <a:latin typeface="Calibri"/>
+              </a:rPr>
+              <a:t>Two independent agentic loops with real statistical acceptance criteria.</a:t>
+            </a:r>
+          </a:p>
+        </p:txBody>
+      </p:sp>
+      <p:sp>
+        <p:nvSpPr>
+          <p:cNvPr id="6" name="Rounded Rectangle 5"/>
+          <p:cNvSpPr/>
+          <p:nvPr/>
+        </p:nvSpPr>
+        <p:spPr>
+          <a:xfrm>
+            <a:off x="3346704" y="4983480"/>
+            <a:ext cx="2615184" cy="1325880"/>
+          </a:xfrm>
+          <a:prstGeom prst="roundRect">
+            <a:avLst>
+              <a:gd name="adj" fmla="val 6000"/>
+            </a:avLst>
+          </a:prstGeom>
+          <a:solidFill>
+            <a:srgbClr val="16141C"/>
+          </a:solidFill>
+          <a:ln w="12700">
+            <a:solidFill>
+              <a:srgbClr val="28242F"/>
+            </a:solidFill>
+          </a:ln>
+          <a:effectLst/>
+        </p:spPr>
+        <p:style>
+          <a:lnRef idx="1">
+            <a:schemeClr val="accent1"/>
+          </a:lnRef>
+          <a:fillRef idx="3">
+            <a:schemeClr val="accent1"/>
+          </a:fillRef>
+          <a:effectRef idx="2">
+            <a:schemeClr val="accent1"/>
+          </a:effectRef>
+          <a:fontRef idx="minor">
+            <a:schemeClr val="lt1"/>
+          </a:fontRef>
+        </p:style>
+        <p:txBody>
+          <a:bodyPr rtlCol="0" anchor="ctr" wrap="square" lIns="137160" tIns="91440"/>
+          <a:lstStyle/>
+          <a:p>
+            <a:pPr algn="l">
+              <a:spcAft>
+                <a:spcPts val="300"/>
+              </a:spcAft>
+            </a:pPr>
+            <a:r>
+              <a:rPr sz="1600" b="1" i="0">
+                <a:solidFill>
+                  <a:srgbClr val="FF3EA5"/>
+                </a:solidFill>
+                <a:latin typeface="Consolas"/>
+              </a:rPr>
+              <a:t>02</a:t>
+            </a:r>
+          </a:p>
+          <a:p>
+            <a:pPr algn="l">
+              <a:spcAft>
+                <a:spcPts val="300"/>
+              </a:spcAft>
+            </a:pPr>
+            <a:r>
+              <a:rPr sz="1200" b="1" i="0">
+                <a:solidFill>
+                  <a:srgbClr val="F4F2F7"/>
+                </a:solidFill>
+                <a:latin typeface="Georgia"/>
+              </a:rPr>
+              <a:t>Reliability under judging</a:t>
+            </a:r>
+          </a:p>
+          <a:p>
+            <a:pPr algn="l">
+              <a:spcAft>
+                <a:spcPts val="0"/>
+              </a:spcAft>
+            </a:pPr>
+            <a:r>
+              <a:rPr sz="950" b="0" i="0">
+                <a:solidFill>
+                  <a:srgbClr val="948FA0"/>
+                </a:solidFill>
+                <a:latin typeface="Calibri"/>
+              </a:rPr>
+              <a:t>3-tier fallback: bad wifi or a dead key degrades the tutor, never crashes the demo.</a:t>
+            </a:r>
+          </a:p>
+        </p:txBody>
+      </p:sp>
+      <p:sp>
+        <p:nvSpPr>
+          <p:cNvPr id="7" name="Rounded Rectangle 6"/>
+          <p:cNvSpPr/>
+          <p:nvPr/>
+        </p:nvSpPr>
+        <p:spPr>
+          <a:xfrm>
+            <a:off x="6053328" y="4983480"/>
+            <a:ext cx="2615184" cy="1325880"/>
+          </a:xfrm>
+          <a:prstGeom prst="roundRect">
+            <a:avLst>
+              <a:gd name="adj" fmla="val 6000"/>
+            </a:avLst>
+          </a:prstGeom>
+          <a:solidFill>
+            <a:srgbClr val="16141C"/>
+          </a:solidFill>
+          <a:ln w="12700">
+            <a:solidFill>
+              <a:srgbClr val="28242F"/>
+            </a:solidFill>
+          </a:ln>
+          <a:effectLst/>
+        </p:spPr>
+        <p:style>
+          <a:lnRef idx="1">
+            <a:schemeClr val="accent1"/>
+          </a:lnRef>
+          <a:fillRef idx="3">
+            <a:schemeClr val="accent1"/>
+          </a:fillRef>
+          <a:effectRef idx="2">
+            <a:schemeClr val="accent1"/>
+          </a:effectRef>
+          <a:fontRef idx="minor">
+            <a:schemeClr val="lt1"/>
+          </a:fontRef>
+        </p:style>
+        <p:txBody>
+          <a:bodyPr rtlCol="0" anchor="ctr" wrap="square" lIns="137160" tIns="91440"/>
+          <a:lstStyle/>
+          <a:p>
+            <a:pPr algn="l">
+              <a:spcAft>
+                <a:spcPts val="300"/>
+              </a:spcAft>
+            </a:pPr>
+            <a:r>
+              <a:rPr sz="1600" b="1" i="0">
+                <a:solidFill>
+                  <a:srgbClr val="FF3EA5"/>
+                </a:solidFill>
+                <a:latin typeface="Consolas"/>
+              </a:rPr>
+              <a:t>03</a:t>
+            </a:r>
+          </a:p>
+          <a:p>
+            <a:pPr algn="l">
+              <a:spcAft>
+                <a:spcPts val="300"/>
+              </a:spcAft>
+            </a:pPr>
+            <a:r>
+              <a:rPr sz="1200" b="1" i="0">
+                <a:solidFill>
+                  <a:srgbClr val="F4F2F7"/>
+                </a:solidFill>
+                <a:latin typeface="Georgia"/>
+              </a:rPr>
+              <a:t>Genuine UX craft</a:t>
+            </a:r>
+          </a:p>
+          <a:p>
+            <a:pPr algn="l">
+              <a:spcAft>
+                <a:spcPts val="0"/>
+              </a:spcAft>
+            </a:pPr>
+            <a:r>
+              <a:rPr sz="950" b="0" i="0">
+                <a:solidFill>
+                  <a:srgbClr val="948FA0"/>
+                </a:solidFill>
+                <a:latin typeface="Calibri"/>
+              </a:rPr>
+              <a:t>Gamified scoring, progress rail, mentor panel, notes - none blocking the core loop.</a:t>
+            </a:r>
+          </a:p>
+        </p:txBody>
+      </p:sp>
+      <p:sp>
+        <p:nvSpPr>
+          <p:cNvPr id="8" name="Rounded Rectangle 7"/>
+          <p:cNvSpPr/>
+          <p:nvPr/>
+        </p:nvSpPr>
+        <p:spPr>
+          <a:xfrm>
+            <a:off x="8759952" y="4983480"/>
+            <a:ext cx="2615184" cy="1325880"/>
+          </a:xfrm>
+          <a:prstGeom prst="roundRect">
+            <a:avLst>
+              <a:gd name="adj" fmla="val 6000"/>
+            </a:avLst>
+          </a:prstGeom>
+          <a:solidFill>
+            <a:srgbClr val="16141C"/>
+          </a:solidFill>
+          <a:ln w="12700">
+            <a:solidFill>
+              <a:srgbClr val="28242F"/>
+            </a:solidFill>
+          </a:ln>
+          <a:effectLst/>
+        </p:spPr>
+        <p:style>
+          <a:lnRef idx="1">
+            <a:schemeClr val="accent1"/>
+          </a:lnRef>
+          <a:fillRef idx="3">
+            <a:schemeClr val="accent1"/>
+          </a:fillRef>
+          <a:effectRef idx="2">
+            <a:schemeClr val="accent1"/>
+          </a:effectRef>
+          <a:fontRef idx="minor">
+            <a:schemeClr val="lt1"/>
+          </a:fontRef>
+        </p:style>
+        <p:txBody>
+          <a:bodyPr rtlCol="0" anchor="ctr" wrap="square" lIns="137160" tIns="91440"/>
+          <a:lstStyle/>
+          <a:p>
+            <a:pPr algn="l">
+              <a:spcAft>
+                <a:spcPts val="300"/>
+              </a:spcAft>
+            </a:pPr>
+            <a:r>
+              <a:rPr sz="1600" b="1" i="0">
+                <a:solidFill>
+                  <a:srgbClr val="FF3EA5"/>
+                </a:solidFill>
+                <a:latin typeface="Consolas"/>
+              </a:rPr>
+              <a:t>04</a:t>
+            </a:r>
+          </a:p>
+          <a:p>
+            <a:pPr algn="l">
+              <a:spcAft>
+                <a:spcPts val="300"/>
+              </a:spcAft>
+            </a:pPr>
+            <a:r>
+              <a:rPr sz="1200" b="1" i="0">
+                <a:solidFill>
+                  <a:srgbClr val="F4F2F7"/>
+                </a:solidFill>
+                <a:latin typeface="Georgia"/>
+              </a:rPr>
+              <a:t>Works on their data</a:t>
+            </a:r>
+          </a:p>
+          <a:p>
+            <a:pPr algn="l">
+              <a:spcAft>
+                <a:spcPts val="0"/>
+              </a:spcAft>
+            </a:pPr>
+            <a:r>
+              <a:rPr sz="950" b="0" i="0">
+                <a:solidFill>
+                  <a:srgbClr val="948FA0"/>
+                </a:solidFill>
+                <a:latin typeface="Calibri"/>
+              </a:rPr>
+              <a:t>Upload any CSV - detection, cleaning, charts, modeling all run live.</a:t>
+            </a:r>
+          </a:p>
+        </p:txBody>
+      </p:sp>
+    </p:spTree>
+  </p:cSld>
+  <p:clrMapOvr>
+    <a:masterClrMapping/>
+  </p:clrMapOvr>
+</p:sld>
+</file>
+
+<file path=ppt/slides/slide11.xml><?xml version="1.0" encoding="utf-8"?>
+<p:sld xmlns:a="http://schemas.openxmlformats.org/drawingml/2006/main" xmlns:p="http://schemas.openxmlformats.org/presentationml/2006/main" xmlns:r="http://schemas.openxmlformats.org/officeDocument/2006/relationships">
+  <p:cSld>
+    <p:bg>
+      <p:bgPr>
+        <a:solidFill>
+          <a:srgbClr val="0B0A10"/>
+        </a:solidFill>
+        <a:effectLst/>
+      </p:bgPr>
+    </p:bg>
+    <p:spTree>
+      <p:nvGrpSpPr>
+        <p:cNvPr id="1" name=""/>
+        <p:cNvGrpSpPr/>
+        <p:nvPr/>
+      </p:nvGrpSpPr>
+      <p:grpSpPr/>
+      <p:sp>
+        <p:nvSpPr>
+          <p:cNvPr id="2" name="TextBox 1"/>
+          <p:cNvSpPr txBox="1"/>
+          <p:nvPr/>
+        </p:nvSpPr>
+        <p:spPr>
+          <a:xfrm>
+            <a:off x="640080" y="457200"/>
+            <a:ext cx="10881360" cy="365760"/>
+          </a:xfrm>
+          <a:prstGeom prst="rect">
+            <a:avLst/>
+          </a:prstGeom>
+          <a:noFill/>
+        </p:spPr>
+        <p:txBody>
+          <a:bodyPr wrap="square">
+            <a:spAutoFit/>
+          </a:bodyPr>
+          <a:lstStyle/>
+          <a:p>
+            <a:pPr algn="l">
+              <a:spcAft>
+                <a:spcPts val="600"/>
+              </a:spcAft>
+            </a:pPr>
+            <a:r>
+              <a:rPr sz="1300" b="1" i="0">
+                <a:solidFill>
+                  <a:srgbClr val="FF3EA5"/>
+                </a:solidFill>
+                <a:latin typeface="Consolas"/>
+              </a:rPr>
+              <a:t>09 — FOR THE DECK</a:t>
             </a:r>
           </a:p>
         </p:txBody>
@@ -8356,7 +9336,7 @@
                 </a:solidFill>
                 <a:latin typeface="Consolas"/>
               </a:rPr>
-              <a:t>05 — LEARNING PATH</a:t>
+              <a:t>05 — TRANSFER LEARNING</a:t>
             </a:r>
           </a:p>
         </p:txBody>
@@ -8395,7 +9375,7 @@
                 </a:solidFill>
                 <a:latin typeface="Georgia"/>
               </a:rPr>
-              <a:t>Six stages, ten real steps</a:t>
+              <a:t>A frozen encoder plus a small trained head</a:t>
             </a:r>
           </a:p>
         </p:txBody>
@@ -8409,7 +9389,7 @@
         <p:spPr>
           <a:xfrm>
             <a:off x="640080" y="1417320"/>
-            <a:ext cx="10881360" cy="548640"/>
+            <a:ext cx="10881360" cy="640080"/>
           </a:xfrm>
           <a:prstGeom prst="rect">
             <a:avLst/>
@@ -8428,27 +9408,625 @@
               </a:spcAft>
             </a:pPr>
             <a:r>
-              <a:rPr sz="1300" b="0" i="0">
+              <a:rPr sz="1400" b="0" i="0">
                 <a:solidFill>
                   <a:srgbClr val="948FA0"/>
                 </a:solidFill>
                 <a:latin typeface="Calibri"/>
               </a:rPr>
-              <a:t>Verification is a bridging step between Cleaning and EDA - real, tested functionality, kept because it's the honest answer to “did the fix actually work?”</a:t>
-            </a:r>
-          </a:p>
-        </p:txBody>
-      </p:sp>
-      <p:sp>
-        <p:nvSpPr>
-          <p:cNvPr id="5" name="TextBox 4"/>
+              <a:t>Before the mentor answers, a small model works out what kind of help the learner is asking for. It only routes: Gemini still writes every reply, and with no encoder the chat behaves as it always did.</a:t>
+            </a:r>
+          </a:p>
+        </p:txBody>
+      </p:sp>
+      <p:sp>
+        <p:nvSpPr>
+          <p:cNvPr id="5" name="Rounded Rectangle 4"/>
+          <p:cNvSpPr/>
+          <p:nvPr/>
+        </p:nvSpPr>
+        <p:spPr>
+          <a:xfrm>
+            <a:off x="640080" y="2194560"/>
+            <a:ext cx="3502152" cy="1325880"/>
+          </a:xfrm>
+          <a:prstGeom prst="roundRect">
+            <a:avLst>
+              <a:gd name="adj" fmla="val 6000"/>
+            </a:avLst>
+          </a:prstGeom>
+          <a:solidFill>
+            <a:srgbClr val="16141C"/>
+          </a:solidFill>
+          <a:ln w="12700">
+            <a:solidFill>
+              <a:srgbClr val="28242F"/>
+            </a:solidFill>
+          </a:ln>
+          <a:effectLst/>
+        </p:spPr>
+        <p:style>
+          <a:lnRef idx="1">
+            <a:schemeClr val="accent1"/>
+          </a:lnRef>
+          <a:fillRef idx="3">
+            <a:schemeClr val="accent1"/>
+          </a:fillRef>
+          <a:effectRef idx="2">
+            <a:schemeClr val="accent1"/>
+          </a:effectRef>
+          <a:fontRef idx="minor">
+            <a:schemeClr val="lt1"/>
+          </a:fontRef>
+        </p:style>
+        <p:txBody>
+          <a:bodyPr rtlCol="0" anchor="ctr" wrap="square" lIns="182880" rIns="182880" tIns="137160" bIns="137160"/>
+          <a:lstStyle/>
+          <a:p>
+            <a:pPr algn="l">
+              <a:spcAft>
+                <a:spcPts val="400"/>
+              </a:spcAft>
+            </a:pPr>
+            <a:r>
+              <a:rPr sz="1400" b="1" i="0">
+                <a:solidFill>
+                  <a:srgbClr val="F4F2F7"/>
+                </a:solidFill>
+                <a:latin typeface="Georgia"/>
+              </a:rPr>
+              <a:t>1  Frozen encoder</a:t>
+            </a:r>
+          </a:p>
+          <a:p>
+            <a:pPr algn="l">
+              <a:spcAft>
+                <a:spcPts val="0"/>
+              </a:spcAft>
+            </a:pPr>
+            <a:r>
+              <a:rPr sz="1200" b="0" i="0">
+                <a:solidFill>
+                  <a:srgbClr val="948FA0"/>
+                </a:solidFill>
+                <a:latin typeface="Calibri"/>
+              </a:rPr>
+              <a:t>BAAI/bge-small-en-v1.5 already understands language. We never retrain it.</a:t>
+            </a:r>
+          </a:p>
+        </p:txBody>
+      </p:sp>
+      <p:sp>
+        <p:nvSpPr>
+          <p:cNvPr id="6" name="Rounded Rectangle 5"/>
+          <p:cNvSpPr/>
+          <p:nvPr/>
+        </p:nvSpPr>
+        <p:spPr>
+          <a:xfrm>
+            <a:off x="4325112" y="2194560"/>
+            <a:ext cx="3502152" cy="1325880"/>
+          </a:xfrm>
+          <a:prstGeom prst="roundRect">
+            <a:avLst>
+              <a:gd name="adj" fmla="val 6000"/>
+            </a:avLst>
+          </a:prstGeom>
+          <a:solidFill>
+            <a:srgbClr val="16141C"/>
+          </a:solidFill>
+          <a:ln w="12700">
+            <a:solidFill>
+              <a:srgbClr val="28242F"/>
+            </a:solidFill>
+          </a:ln>
+          <a:effectLst/>
+        </p:spPr>
+        <p:style>
+          <a:lnRef idx="1">
+            <a:schemeClr val="accent1"/>
+          </a:lnRef>
+          <a:fillRef idx="3">
+            <a:schemeClr val="accent1"/>
+          </a:fillRef>
+          <a:effectRef idx="2">
+            <a:schemeClr val="accent1"/>
+          </a:effectRef>
+          <a:fontRef idx="minor">
+            <a:schemeClr val="lt1"/>
+          </a:fontRef>
+        </p:style>
+        <p:txBody>
+          <a:bodyPr rtlCol="0" anchor="ctr" wrap="square" lIns="182880" rIns="182880" tIns="137160" bIns="137160"/>
+          <a:lstStyle/>
+          <a:p>
+            <a:pPr algn="l">
+              <a:spcAft>
+                <a:spcPts val="400"/>
+              </a:spcAft>
+            </a:pPr>
+            <a:r>
+              <a:rPr sz="1400" b="1" i="0">
+                <a:solidFill>
+                  <a:srgbClr val="F4F2F7"/>
+                </a:solidFill>
+                <a:latin typeface="Georgia"/>
+              </a:rPr>
+              <a:t>2  Small trained head</a:t>
+            </a:r>
+          </a:p>
+          <a:p>
+            <a:pPr algn="l">
+              <a:spcAft>
+                <a:spcPts val="0"/>
+              </a:spcAft>
+            </a:pPr>
+            <a:r>
+              <a:rPr sz="1200" b="0" i="0">
+                <a:solidFill>
+                  <a:srgbClr val="948FA0"/>
+                </a:solidFill>
+                <a:latin typeface="Calibri"/>
+              </a:rPr>
+              <a:t>Logistic regression on 186 labelled learner questions picks one of 7 intents, or says it is not sure.</a:t>
+            </a:r>
+          </a:p>
+        </p:txBody>
+      </p:sp>
+      <p:sp>
+        <p:nvSpPr>
+          <p:cNvPr id="7" name="Rounded Rectangle 6"/>
+          <p:cNvSpPr/>
+          <p:nvPr/>
+        </p:nvSpPr>
+        <p:spPr>
+          <a:xfrm>
+            <a:off x="8010144" y="2194560"/>
+            <a:ext cx="3502152" cy="1325880"/>
+          </a:xfrm>
+          <a:prstGeom prst="roundRect">
+            <a:avLst>
+              <a:gd name="adj" fmla="val 6000"/>
+            </a:avLst>
+          </a:prstGeom>
+          <a:solidFill>
+            <a:srgbClr val="16141C"/>
+          </a:solidFill>
+          <a:ln w="12700">
+            <a:solidFill>
+              <a:srgbClr val="28242F"/>
+            </a:solidFill>
+          </a:ln>
+          <a:effectLst/>
+        </p:spPr>
+        <p:style>
+          <a:lnRef idx="1">
+            <a:schemeClr val="accent1"/>
+          </a:lnRef>
+          <a:fillRef idx="3">
+            <a:schemeClr val="accent1"/>
+          </a:fillRef>
+          <a:effectRef idx="2">
+            <a:schemeClr val="accent1"/>
+          </a:effectRef>
+          <a:fontRef idx="minor">
+            <a:schemeClr val="lt1"/>
+          </a:fontRef>
+        </p:style>
+        <p:txBody>
+          <a:bodyPr rtlCol="0" anchor="ctr" wrap="square" lIns="182880" rIns="182880" tIns="137160" bIns="137160"/>
+          <a:lstStyle/>
+          <a:p>
+            <a:pPr algn="l">
+              <a:spcAft>
+                <a:spcPts val="400"/>
+              </a:spcAft>
+            </a:pPr>
+            <a:r>
+              <a:rPr sz="1400" b="1" i="0">
+                <a:solidFill>
+                  <a:srgbClr val="F4F2F7"/>
+                </a:solidFill>
+                <a:latin typeface="Georgia"/>
+              </a:rPr>
+              <a:t>3  Tailored reply</a:t>
+            </a:r>
+          </a:p>
+          <a:p>
+            <a:pPr algn="l">
+              <a:spcAft>
+                <a:spcPts val="0"/>
+              </a:spcAft>
+            </a:pPr>
+            <a:r>
+              <a:rPr sz="1200" b="0" i="0">
+                <a:solidFill>
+                  <a:srgbClr val="948FA0"/>
+                </a:solidFill>
+                <a:latin typeface="Calibri"/>
+              </a:rPr>
+              <a:t>The intent, the learner's level and their role, experience and goal shape the prompt.</a:t>
+            </a:r>
+          </a:p>
+        </p:txBody>
+      </p:sp>
+      <p:graphicFrame>
+        <p:nvGraphicFramePr>
+          <p:cNvPr id="8" name="Table 7"/>
+          <p:cNvGraphicFramePr>
+            <a:graphicFrameLocks noGrp="1"/>
+          </p:cNvGraphicFramePr>
+          <p:nvPr/>
+        </p:nvGraphicFramePr>
+        <p:xfrm>
+          <a:off x="640080" y="3749039"/>
+          <a:ext cx="10881360" cy="1828800"/>
+        </p:xfrm>
+        <a:graphic>
+          <a:graphicData uri="http://schemas.openxmlformats.org/drawingml/2006/table">
+            <a:tbl>
+              <a:tblPr firstRow="1" bandRow="1">
+                <a:tableStyleId>{5C22544A-7EE6-4342-B048-85BDC9FD1C3A}</a:tableStyleId>
+              </a:tblPr>
+              <a:tblGrid>
+                <a:gridCol w="5943600"/>
+                <a:gridCol w="2468880"/>
+                <a:gridCol w="2468880"/>
+              </a:tblGrid>
+              <a:tr h="365760">
+                <a:tc>
+                  <a:txBody>
+                    <a:bodyPr/>
+                    <a:lstStyle/>
+                    <a:p>
+                      <a:r>
+                        <a:rPr sz="1000" b="1" i="0">
+                          <a:solidFill>
+                            <a:srgbClr val="635D6E"/>
+                          </a:solidFill>
+                          <a:latin typeface="Consolas"/>
+                        </a:rPr>
+                        <a:t>Test</a:t>
+                      </a:r>
+                    </a:p>
+                  </a:txBody>
+                  <a:tcPr marL="109728" anchor="ctr">
+                    <a:solidFill>
+                      <a:srgbClr val="1D1A25"/>
+                    </a:solidFill>
+                  </a:tcPr>
+                </a:tc>
+                <a:tc>
+                  <a:txBody>
+                    <a:bodyPr/>
+                    <a:lstStyle/>
+                    <a:p>
+                      <a:r>
+                        <a:rPr sz="1000" b="1" i="0">
+                          <a:solidFill>
+                            <a:srgbClr val="635D6E"/>
+                          </a:solidFill>
+                          <a:latin typeface="Consolas"/>
+                        </a:rPr>
+                        <a:t>Transfer</a:t>
+                      </a:r>
+                    </a:p>
+                  </a:txBody>
+                  <a:tcPr marL="109728" anchor="ctr">
+                    <a:solidFill>
+                      <a:srgbClr val="1D1A25"/>
+                    </a:solidFill>
+                  </a:tcPr>
+                </a:tc>
+                <a:tc>
+                  <a:txBody>
+                    <a:bodyPr/>
+                    <a:lstStyle/>
+                    <a:p>
+                      <a:r>
+                        <a:rPr sz="1000" b="1" i="0">
+                          <a:solidFill>
+                            <a:srgbClr val="635D6E"/>
+                          </a:solidFill>
+                          <a:latin typeface="Consolas"/>
+                        </a:rPr>
+                        <a:t>Baseline (TF-IDF)</a:t>
+                      </a:r>
+                    </a:p>
+                  </a:txBody>
+                  <a:tcPr marL="109728" anchor="ctr">
+                    <a:solidFill>
+                      <a:srgbClr val="1D1A25"/>
+                    </a:solidFill>
+                  </a:tcPr>
+                </a:tc>
+              </a:tr>
+              <a:tr h="365760">
+                <a:tc>
+                  <a:txBody>
+                    <a:bodyPr/>
+                    <a:lstStyle/>
+                    <a:p>
+                      <a:r>
+                        <a:rPr sz="1200" b="0" i="0">
+                          <a:solidFill>
+                            <a:srgbClr val="F4F2F7"/>
+                          </a:solidFill>
+                          <a:latin typeface="Calibri"/>
+                        </a:rPr>
+                        <a:t>5-fold cross-validation, 186 questions</a:t>
+                      </a:r>
+                    </a:p>
+                  </a:txBody>
+                  <a:tcPr marL="109728" anchor="ctr">
+                    <a:solidFill>
+                      <a:srgbClr val="16141C"/>
+                    </a:solidFill>
+                  </a:tcPr>
+                </a:tc>
+                <a:tc>
+                  <a:txBody>
+                    <a:bodyPr/>
+                    <a:lstStyle/>
+                    <a:p>
+                      <a:r>
+                        <a:rPr sz="1200" b="1" i="0">
+                          <a:solidFill>
+                            <a:srgbClr val="3DDC8A"/>
+                          </a:solidFill>
+                          <a:latin typeface="Calibri"/>
+                        </a:rPr>
+                        <a:t>93.5%</a:t>
+                      </a:r>
+                    </a:p>
+                  </a:txBody>
+                  <a:tcPr marL="109728" anchor="ctr">
+                    <a:solidFill>
+                      <a:srgbClr val="16141C"/>
+                    </a:solidFill>
+                  </a:tcPr>
+                </a:tc>
+                <a:tc>
+                  <a:txBody>
+                    <a:bodyPr/>
+                    <a:lstStyle/>
+                    <a:p>
+                      <a:r>
+                        <a:rPr sz="1200" b="0" i="0">
+                          <a:solidFill>
+                            <a:srgbClr val="948FA0"/>
+                          </a:solidFill>
+                          <a:latin typeface="Calibri"/>
+                        </a:rPr>
+                        <a:t>71.0%</a:t>
+                      </a:r>
+                    </a:p>
+                  </a:txBody>
+                  <a:tcPr marL="109728" anchor="ctr">
+                    <a:solidFill>
+                      <a:srgbClr val="16141C"/>
+                    </a:solidFill>
+                  </a:tcPr>
+                </a:tc>
+              </a:tr>
+              <a:tr h="365760">
+                <a:tc>
+                  <a:txBody>
+                    <a:bodyPr/>
+                    <a:lstStyle/>
+                    <a:p>
+                      <a:r>
+                        <a:rPr sz="1200" b="0" i="0">
+                          <a:solidFill>
+                            <a:srgbClr val="F4F2F7"/>
+                          </a:solidFill>
+                          <a:latin typeface="Calibri"/>
+                        </a:rPr>
+                        <a:t>Only 2 labelled examples per intent</a:t>
+                      </a:r>
+                    </a:p>
+                  </a:txBody>
+                  <a:tcPr marL="109728" anchor="ctr">
+                    <a:solidFill>
+                      <a:srgbClr val="16141C"/>
+                    </a:solidFill>
+                  </a:tcPr>
+                </a:tc>
+                <a:tc>
+                  <a:txBody>
+                    <a:bodyPr/>
+                    <a:lstStyle/>
+                    <a:p>
+                      <a:r>
+                        <a:rPr sz="1200" b="1" i="0">
+                          <a:solidFill>
+                            <a:srgbClr val="3DDC8A"/>
+                          </a:solidFill>
+                          <a:latin typeface="Calibri"/>
+                        </a:rPr>
+                        <a:t>73.2%</a:t>
+                      </a:r>
+                    </a:p>
+                  </a:txBody>
+                  <a:tcPr marL="109728" anchor="ctr">
+                    <a:solidFill>
+                      <a:srgbClr val="16141C"/>
+                    </a:solidFill>
+                  </a:tcPr>
+                </a:tc>
+                <a:tc>
+                  <a:txBody>
+                    <a:bodyPr/>
+                    <a:lstStyle/>
+                    <a:p>
+                      <a:r>
+                        <a:rPr sz="1200" b="0" i="0">
+                          <a:solidFill>
+                            <a:srgbClr val="948FA0"/>
+                          </a:solidFill>
+                          <a:latin typeface="Calibri"/>
+                        </a:rPr>
+                        <a:t>41.1%</a:t>
+                      </a:r>
+                    </a:p>
+                  </a:txBody>
+                  <a:tcPr marL="109728" anchor="ctr">
+                    <a:solidFill>
+                      <a:srgbClr val="16141C"/>
+                    </a:solidFill>
+                  </a:tcPr>
+                </a:tc>
+              </a:tr>
+              <a:tr h="365760">
+                <a:tc>
+                  <a:txBody>
+                    <a:bodyPr/>
+                    <a:lstStyle/>
+                    <a:p>
+                      <a:r>
+                        <a:rPr sz="1200" b="0" i="0">
+                          <a:solidFill>
+                            <a:srgbClr val="F4F2F7"/>
+                          </a:solidFill>
+                          <a:latin typeface="Calibri"/>
+                        </a:rPr>
+                        <a:t>Only 8 labelled examples per intent</a:t>
+                      </a:r>
+                    </a:p>
+                  </a:txBody>
+                  <a:tcPr marL="109728" anchor="ctr">
+                    <a:solidFill>
+                      <a:srgbClr val="16141C"/>
+                    </a:solidFill>
+                  </a:tcPr>
+                </a:tc>
+                <a:tc>
+                  <a:txBody>
+                    <a:bodyPr/>
+                    <a:lstStyle/>
+                    <a:p>
+                      <a:r>
+                        <a:rPr sz="1200" b="1" i="0">
+                          <a:solidFill>
+                            <a:srgbClr val="3DDC8A"/>
+                          </a:solidFill>
+                          <a:latin typeface="Calibri"/>
+                        </a:rPr>
+                        <a:t>87.1%</a:t>
+                      </a:r>
+                    </a:p>
+                  </a:txBody>
+                  <a:tcPr marL="109728" anchor="ctr">
+                    <a:solidFill>
+                      <a:srgbClr val="16141C"/>
+                    </a:solidFill>
+                  </a:tcPr>
+                </a:tc>
+                <a:tc>
+                  <a:txBody>
+                    <a:bodyPr/>
+                    <a:lstStyle/>
+                    <a:p>
+                      <a:r>
+                        <a:rPr sz="1200" b="0" i="0">
+                          <a:solidFill>
+                            <a:srgbClr val="948FA0"/>
+                          </a:solidFill>
+                          <a:latin typeface="Calibri"/>
+                        </a:rPr>
+                        <a:t>57.9%</a:t>
+                      </a:r>
+                    </a:p>
+                  </a:txBody>
+                  <a:tcPr marL="109728" anchor="ctr">
+                    <a:solidFill>
+                      <a:srgbClr val="16141C"/>
+                    </a:solidFill>
+                  </a:tcPr>
+                </a:tc>
+              </a:tr>
+              <a:tr h="365760">
+                <a:tc>
+                  <a:txBody>
+                    <a:bodyPr/>
+                    <a:lstStyle/>
+                    <a:p>
+                      <a:r>
+                        <a:rPr sz="1200" b="0" i="0">
+                          <a:solidFill>
+                            <a:srgbClr val="F4F2F7"/>
+                          </a:solidFill>
+                          <a:latin typeface="Calibri"/>
+                        </a:rPr>
+                        <a:t>Only 16 labelled examples per intent</a:t>
+                      </a:r>
+                    </a:p>
+                  </a:txBody>
+                  <a:tcPr marL="109728" anchor="ctr">
+                    <a:solidFill>
+                      <a:srgbClr val="16141C"/>
+                    </a:solidFill>
+                  </a:tcPr>
+                </a:tc>
+                <a:tc>
+                  <a:txBody>
+                    <a:bodyPr/>
+                    <a:lstStyle/>
+                    <a:p>
+                      <a:r>
+                        <a:rPr sz="1200" b="1" i="0">
+                          <a:solidFill>
+                            <a:srgbClr val="3DDC8A"/>
+                          </a:solidFill>
+                          <a:latin typeface="Calibri"/>
+                        </a:rPr>
+                        <a:t>90.4%</a:t>
+                      </a:r>
+                    </a:p>
+                  </a:txBody>
+                  <a:tcPr marL="109728" anchor="ctr">
+                    <a:solidFill>
+                      <a:srgbClr val="16141C"/>
+                    </a:solidFill>
+                  </a:tcPr>
+                </a:tc>
+                <a:tc>
+                  <a:txBody>
+                    <a:bodyPr/>
+                    <a:lstStyle/>
+                    <a:p>
+                      <a:r>
+                        <a:rPr sz="1200" b="0" i="0">
+                          <a:solidFill>
+                            <a:srgbClr val="948FA0"/>
+                          </a:solidFill>
+                          <a:latin typeface="Calibri"/>
+                        </a:rPr>
+                        <a:t>62.1%</a:t>
+                      </a:r>
+                    </a:p>
+                  </a:txBody>
+                  <a:tcPr marL="109728" anchor="ctr">
+                    <a:solidFill>
+                      <a:srgbClr val="16141C"/>
+                    </a:solidFill>
+                  </a:tcPr>
+                </a:tc>
+              </a:tr>
+            </a:tbl>
+          </a:graphicData>
+        </a:graphic>
+      </p:graphicFrame>
+      <p:sp>
+        <p:nvSpPr>
+          <p:cNvPr id="9" name="TextBox 8"/>
           <p:cNvSpPr txBox="1"/>
           <p:nvPr/>
         </p:nvSpPr>
         <p:spPr>
           <a:xfrm>
-            <a:off x="640080" y="2057400"/>
-            <a:ext cx="457200" cy="576072"/>
+            <a:off x="640080" y="5669280"/>
+            <a:ext cx="10881360" cy="731520"/>
           </a:xfrm>
           <a:prstGeom prst="rect">
             <a:avLst/>
@@ -8467,27 +10045,27 @@
               </a:spcAft>
             </a:pPr>
             <a:r>
-              <a:rPr sz="1200" b="0" i="0">
-                <a:solidFill>
-                  <a:srgbClr val="FF3EA5"/>
-                </a:solidFill>
-                <a:latin typeface="Consolas"/>
-              </a:rPr>
-              <a:t>01</a:t>
-            </a:r>
-          </a:p>
-        </p:txBody>
-      </p:sp>
-      <p:sp>
-        <p:nvSpPr>
-          <p:cNvPr id="6" name="TextBox 5"/>
+              <a:rPr sz="1100" b="0" i="0">
+                <a:solidFill>
+                  <a:srgbClr val="948FA0"/>
+                </a:solidFill>
+                <a:latin typeface="Calibri"/>
+              </a:rPr>
+              <a:t>On 56 held-out messages: 98.2% with no wrong labels, and the baseline reaches 92.9% there, so the gap is small. We wrote those messages ourselves, which makes them easier than real learners. The few-shot rows are the real evidence.</a:t>
+            </a:r>
+          </a:p>
+        </p:txBody>
+      </p:sp>
+      <p:sp>
+        <p:nvSpPr>
+          <p:cNvPr id="10" name="TextBox 9"/>
           <p:cNvSpPr txBox="1"/>
           <p:nvPr/>
         </p:nvSpPr>
         <p:spPr>
           <a:xfrm>
-            <a:off x="1188720" y="2057400"/>
-            <a:ext cx="10332720" cy="576072"/>
+            <a:off x="640080" y="6446520"/>
+            <a:ext cx="10881360" cy="320040"/>
           </a:xfrm>
           <a:prstGeom prst="rect">
             <a:avLst/>
@@ -8500,554 +10078,19 @@
           </a:bodyPr>
           <a:lstStyle/>
           <a:p>
-            <a:r>
-              <a:rPr sz="1300" b="1" i="0">
-                <a:solidFill>
-                  <a:srgbClr val="F4F2F7"/>
-                </a:solidFill>
-                <a:latin typeface="Georgia"/>
-              </a:rPr>
-              <a:t>Python &amp; Data Fundamentals  </a:t>
-            </a:r>
-            <a:r>
-              <a:rPr sz="1100" b="0" i="0">
-                <a:solidFill>
-                  <a:srgbClr val="948FA0"/>
-                </a:solidFill>
-                <a:latin typeface="Calibri"/>
-              </a:rPr>
-              <a:t>Read a CSV, understand rows/columns, real pd.read_csv / df.shape / df.columns.</a:t>
-            </a:r>
-          </a:p>
-        </p:txBody>
-      </p:sp>
-      <p:sp>
-        <p:nvSpPr>
-          <p:cNvPr id="7" name="TextBox 6"/>
-          <p:cNvSpPr txBox="1"/>
-          <p:nvPr/>
-        </p:nvSpPr>
-        <p:spPr>
-          <a:xfrm>
-            <a:off x="640080" y="2633472"/>
-            <a:ext cx="457200" cy="576072"/>
-          </a:xfrm>
-          <a:prstGeom prst="rect">
-            <a:avLst/>
-          </a:prstGeom>
-          <a:noFill/>
-        </p:spPr>
-        <p:txBody>
-          <a:bodyPr wrap="square">
-            <a:spAutoFit/>
-          </a:bodyPr>
-          <a:lstStyle/>
-          <a:p>
             <a:pPr algn="l">
               <a:spcAft>
                 <a:spcPts val="600"/>
               </a:spcAft>
             </a:pPr>
             <a:r>
-              <a:rPr sz="1200" b="0" i="0">
-                <a:solidFill>
-                  <a:srgbClr val="FF3EA5"/>
+              <a:rPr sz="900" b="0" i="0">
+                <a:solidFill>
+                  <a:srgbClr val="635D6E"/>
                 </a:solidFill>
                 <a:latin typeface="Consolas"/>
               </a:rPr>
-              <a:t>02</a:t>
-            </a:r>
-          </a:p>
-        </p:txBody>
-      </p:sp>
-      <p:sp>
-        <p:nvSpPr>
-          <p:cNvPr id="8" name="TextBox 7"/>
-          <p:cNvSpPr txBox="1"/>
-          <p:nvPr/>
-        </p:nvSpPr>
-        <p:spPr>
-          <a:xfrm>
-            <a:off x="1188720" y="2633472"/>
-            <a:ext cx="10332720" cy="576072"/>
-          </a:xfrm>
-          <a:prstGeom prst="rect">
-            <a:avLst/>
-          </a:prstGeom>
-          <a:noFill/>
-        </p:spPr>
-        <p:txBody>
-          <a:bodyPr wrap="square">
-            <a:spAutoFit/>
-          </a:bodyPr>
-          <a:lstStyle/>
-          <a:p>
-            <a:r>
-              <a:rPr sz="1300" b="1" i="0">
-                <a:solidFill>
-                  <a:srgbClr val="F4F2F7"/>
-                </a:solidFill>
-                <a:latin typeface="Georgia"/>
-              </a:rPr>
-              <a:t>Data Cleaning  </a:t>
-            </a:r>
-            <a:r>
-              <a:rPr sz="1100" b="0" i="0">
-                <a:solidFill>
-                  <a:srgbClr val="948FA0"/>
-                </a:solidFill>
-                <a:latin typeface="Calibri"/>
-              </a:rPr>
-              <a:t>One level per detected issue. ⏭ “Skip cleaning” jumps straight to Verification.</a:t>
-            </a:r>
-          </a:p>
-        </p:txBody>
-      </p:sp>
-      <p:sp>
-        <p:nvSpPr>
-          <p:cNvPr id="9" name="TextBox 8"/>
-          <p:cNvSpPr txBox="1"/>
-          <p:nvPr/>
-        </p:nvSpPr>
-        <p:spPr>
-          <a:xfrm>
-            <a:off x="640080" y="3209544"/>
-            <a:ext cx="457200" cy="576072"/>
-          </a:xfrm>
-          <a:prstGeom prst="rect">
-            <a:avLst/>
-          </a:prstGeom>
-          <a:noFill/>
-        </p:spPr>
-        <p:txBody>
-          <a:bodyPr wrap="square">
-            <a:spAutoFit/>
-          </a:bodyPr>
-          <a:lstStyle/>
-          <a:p>
-            <a:pPr algn="l">
-              <a:spcAft>
-                <a:spcPts val="600"/>
-              </a:spcAft>
-            </a:pPr>
-            <a:r>
-              <a:rPr sz="1200" b="0" i="0">
-                <a:solidFill>
-                  <a:srgbClr val="FF3EA5"/>
-                </a:solidFill>
-                <a:latin typeface="Consolas"/>
-              </a:rPr>
-              <a:t>—</a:t>
-            </a:r>
-          </a:p>
-        </p:txBody>
-      </p:sp>
-      <p:sp>
-        <p:nvSpPr>
-          <p:cNvPr id="10" name="TextBox 9"/>
-          <p:cNvSpPr txBox="1"/>
-          <p:nvPr/>
-        </p:nvSpPr>
-        <p:spPr>
-          <a:xfrm>
-            <a:off x="1188720" y="3209544"/>
-            <a:ext cx="10332720" cy="576072"/>
-          </a:xfrm>
-          <a:prstGeom prst="rect">
-            <a:avLst/>
-          </a:prstGeom>
-          <a:noFill/>
-        </p:spPr>
-        <p:txBody>
-          <a:bodyPr wrap="square">
-            <a:spAutoFit/>
-          </a:bodyPr>
-          <a:lstStyle/>
-          <a:p>
-            <a:r>
-              <a:rPr sz="1300" b="1" i="0">
-                <a:solidFill>
-                  <a:srgbClr val="F4F2F7"/>
-                </a:solidFill>
-                <a:latin typeface="Georgia"/>
-              </a:rPr>
-              <a:t>Verification (bridge)  </a:t>
-            </a:r>
-            <a:r>
-              <a:rPr sz="1100" b="0" i="0">
-                <a:solidFill>
-                  <a:srgbClr val="948FA0"/>
-                </a:solidFill>
-                <a:latin typeface="Calibri"/>
-              </a:rPr>
-              <a:t>Real downstream tasks on cleaned data - aggregation, a bar chart, a trend line.</a:t>
-            </a:r>
-          </a:p>
-        </p:txBody>
-      </p:sp>
-      <p:sp>
-        <p:nvSpPr>
-          <p:cNvPr id="11" name="TextBox 10"/>
-          <p:cNvSpPr txBox="1"/>
-          <p:nvPr/>
-        </p:nvSpPr>
-        <p:spPr>
-          <a:xfrm>
-            <a:off x="640080" y="3785616"/>
-            <a:ext cx="457200" cy="576072"/>
-          </a:xfrm>
-          <a:prstGeom prst="rect">
-            <a:avLst/>
-          </a:prstGeom>
-          <a:noFill/>
-        </p:spPr>
-        <p:txBody>
-          <a:bodyPr wrap="square">
-            <a:spAutoFit/>
-          </a:bodyPr>
-          <a:lstStyle/>
-          <a:p>
-            <a:pPr algn="l">
-              <a:spcAft>
-                <a:spcPts val="600"/>
-              </a:spcAft>
-            </a:pPr>
-            <a:r>
-              <a:rPr sz="1200" b="0" i="0">
-                <a:solidFill>
-                  <a:srgbClr val="FF3EA5"/>
-                </a:solidFill>
-                <a:latin typeface="Consolas"/>
-              </a:rPr>
-              <a:t>03</a:t>
-            </a:r>
-          </a:p>
-        </p:txBody>
-      </p:sp>
-      <p:sp>
-        <p:nvSpPr>
-          <p:cNvPr id="12" name="TextBox 11"/>
-          <p:cNvSpPr txBox="1"/>
-          <p:nvPr/>
-        </p:nvSpPr>
-        <p:spPr>
-          <a:xfrm>
-            <a:off x="1188720" y="3785616"/>
-            <a:ext cx="10332720" cy="576072"/>
-          </a:xfrm>
-          <a:prstGeom prst="rect">
-            <a:avLst/>
-          </a:prstGeom>
-          <a:noFill/>
-        </p:spPr>
-        <p:txBody>
-          <a:bodyPr wrap="square">
-            <a:spAutoFit/>
-          </a:bodyPr>
-          <a:lstStyle/>
-          <a:p>
-            <a:r>
-              <a:rPr sz="1300" b="1" i="0">
-                <a:solidFill>
-                  <a:srgbClr val="F4F2F7"/>
-                </a:solidFill>
-                <a:latin typeface="Georgia"/>
-              </a:rPr>
-              <a:t>Exploratory Data Analysis  </a:t>
-            </a:r>
-            <a:r>
-              <a:rPr sz="1100" b="0" i="0">
-                <a:solidFill>
-                  <a:srgbClr val="948FA0"/>
-                </a:solidFill>
-                <a:latin typeface="Calibri"/>
-              </a:rPr>
-              <a:t>Real histograms, category bars, trend - plus a correlation card.</a:t>
-            </a:r>
-          </a:p>
-        </p:txBody>
-      </p:sp>
-      <p:sp>
-        <p:nvSpPr>
-          <p:cNvPr id="13" name="TextBox 12"/>
-          <p:cNvSpPr txBox="1"/>
-          <p:nvPr/>
-        </p:nvSpPr>
-        <p:spPr>
-          <a:xfrm>
-            <a:off x="640080" y="4361688"/>
-            <a:ext cx="457200" cy="576072"/>
-          </a:xfrm>
-          <a:prstGeom prst="rect">
-            <a:avLst/>
-          </a:prstGeom>
-          <a:noFill/>
-        </p:spPr>
-        <p:txBody>
-          <a:bodyPr wrap="square">
-            <a:spAutoFit/>
-          </a:bodyPr>
-          <a:lstStyle/>
-          <a:p>
-            <a:pPr algn="l">
-              <a:spcAft>
-                <a:spcPts val="600"/>
-              </a:spcAft>
-            </a:pPr>
-            <a:r>
-              <a:rPr sz="1200" b="0" i="0">
-                <a:solidFill>
-                  <a:srgbClr val="FF3EA5"/>
-                </a:solidFill>
-                <a:latin typeface="Consolas"/>
-              </a:rPr>
-              <a:t>04</a:t>
-            </a:r>
-          </a:p>
-        </p:txBody>
-      </p:sp>
-      <p:sp>
-        <p:nvSpPr>
-          <p:cNvPr id="14" name="TextBox 13"/>
-          <p:cNvSpPr txBox="1"/>
-          <p:nvPr/>
-        </p:nvSpPr>
-        <p:spPr>
-          <a:xfrm>
-            <a:off x="1188720" y="4361688"/>
-            <a:ext cx="10332720" cy="576072"/>
-          </a:xfrm>
-          <a:prstGeom prst="rect">
-            <a:avLst/>
-          </a:prstGeom>
-          <a:noFill/>
-        </p:spPr>
-        <p:txBody>
-          <a:bodyPr wrap="square">
-            <a:spAutoFit/>
-          </a:bodyPr>
-          <a:lstStyle/>
-          <a:p>
-            <a:r>
-              <a:rPr sz="1300" b="1" i="0">
-                <a:solidFill>
-                  <a:srgbClr val="F4F2F7"/>
-                </a:solidFill>
-                <a:latin typeface="Georgia"/>
-              </a:rPr>
-              <a:t>Machine Learning Foundations  </a:t>
-            </a:r>
-            <a:r>
-              <a:rPr sz="1100" b="0" i="0">
-                <a:solidFill>
-                  <a:srgbClr val="948FA0"/>
-                </a:solidFill>
-                <a:latin typeface="Calibri"/>
-              </a:rPr>
-              <a:t>Target, features, train/test split, regression vs. classification.</a:t>
-            </a:r>
-          </a:p>
-        </p:txBody>
-      </p:sp>
-      <p:sp>
-        <p:nvSpPr>
-          <p:cNvPr id="15" name="TextBox 14"/>
-          <p:cNvSpPr txBox="1"/>
-          <p:nvPr/>
-        </p:nvSpPr>
-        <p:spPr>
-          <a:xfrm>
-            <a:off x="640080" y="4937760"/>
-            <a:ext cx="457200" cy="576072"/>
-          </a:xfrm>
-          <a:prstGeom prst="rect">
-            <a:avLst/>
-          </a:prstGeom>
-          <a:noFill/>
-        </p:spPr>
-        <p:txBody>
-          <a:bodyPr wrap="square">
-            <a:spAutoFit/>
-          </a:bodyPr>
-          <a:lstStyle/>
-          <a:p>
-            <a:pPr algn="l">
-              <a:spcAft>
-                <a:spcPts val="600"/>
-              </a:spcAft>
-            </a:pPr>
-            <a:r>
-              <a:rPr sz="1200" b="0" i="0">
-                <a:solidFill>
-                  <a:srgbClr val="FF3EA5"/>
-                </a:solidFill>
-                <a:latin typeface="Consolas"/>
-              </a:rPr>
-              <a:t>05</a:t>
-            </a:r>
-          </a:p>
-        </p:txBody>
-      </p:sp>
-      <p:sp>
-        <p:nvSpPr>
-          <p:cNvPr id="16" name="TextBox 15"/>
-          <p:cNvSpPr txBox="1"/>
-          <p:nvPr/>
-        </p:nvSpPr>
-        <p:spPr>
-          <a:xfrm>
-            <a:off x="1188720" y="4937760"/>
-            <a:ext cx="10332720" cy="576072"/>
-          </a:xfrm>
-          <a:prstGeom prst="rect">
-            <a:avLst/>
-          </a:prstGeom>
-          <a:noFill/>
-        </p:spPr>
-        <p:txBody>
-          <a:bodyPr wrap="square">
-            <a:spAutoFit/>
-          </a:bodyPr>
-          <a:lstStyle/>
-          <a:p>
-            <a:r>
-              <a:rPr sz="1300" b="1" i="0">
-                <a:solidFill>
-                  <a:srgbClr val="F4F2F7"/>
-                </a:solidFill>
-                <a:latin typeface="Georgia"/>
-              </a:rPr>
-              <a:t>Model Selection &amp; Evaluation  </a:t>
-            </a:r>
-            <a:r>
-              <a:rPr sz="1100" b="0" i="0">
-                <a:solidFill>
-                  <a:srgbClr val="948FA0"/>
-                </a:solidFill>
-                <a:latin typeface="Calibri"/>
-              </a:rPr>
-              <a:t>The second agentic loop, narrated. ⏭ “Skip modeling” available.</a:t>
-            </a:r>
-          </a:p>
-        </p:txBody>
-      </p:sp>
-      <p:sp>
-        <p:nvSpPr>
-          <p:cNvPr id="17" name="TextBox 16"/>
-          <p:cNvSpPr txBox="1"/>
-          <p:nvPr/>
-        </p:nvSpPr>
-        <p:spPr>
-          <a:xfrm>
-            <a:off x="640080" y="5513832"/>
-            <a:ext cx="457200" cy="576072"/>
-          </a:xfrm>
-          <a:prstGeom prst="rect">
-            <a:avLst/>
-          </a:prstGeom>
-          <a:noFill/>
-        </p:spPr>
-        <p:txBody>
-          <a:bodyPr wrap="square">
-            <a:spAutoFit/>
-          </a:bodyPr>
-          <a:lstStyle/>
-          <a:p>
-            <a:pPr algn="l">
-              <a:spcAft>
-                <a:spcPts val="600"/>
-              </a:spcAft>
-            </a:pPr>
-            <a:r>
-              <a:rPr sz="1200" b="0" i="0">
-                <a:solidFill>
-                  <a:srgbClr val="FF3EA5"/>
-                </a:solidFill>
-                <a:latin typeface="Consolas"/>
-              </a:rPr>
-              <a:t>06</a:t>
-            </a:r>
-          </a:p>
-        </p:txBody>
-      </p:sp>
-      <p:sp>
-        <p:nvSpPr>
-          <p:cNvPr id="18" name="TextBox 17"/>
-          <p:cNvSpPr txBox="1"/>
-          <p:nvPr/>
-        </p:nvSpPr>
-        <p:spPr>
-          <a:xfrm>
-            <a:off x="1188720" y="5513832"/>
-            <a:ext cx="10332720" cy="576072"/>
-          </a:xfrm>
-          <a:prstGeom prst="rect">
-            <a:avLst/>
-          </a:prstGeom>
-          <a:noFill/>
-        </p:spPr>
-        <p:txBody>
-          <a:bodyPr wrap="square">
-            <a:spAutoFit/>
-          </a:bodyPr>
-          <a:lstStyle/>
-          <a:p>
-            <a:r>
-              <a:rPr sz="1300" b="1" i="0">
-                <a:solidFill>
-                  <a:srgbClr val="F4F2F7"/>
-                </a:solidFill>
-                <a:latin typeface="Georgia"/>
-              </a:rPr>
-              <a:t>Final Project  </a:t>
-            </a:r>
-            <a:r>
-              <a:rPr sz="1100" b="0" i="0">
-                <a:solidFill>
-                  <a:srgbClr val="948FA0"/>
-                </a:solidFill>
-                <a:latin typeface="Calibri"/>
-              </a:rPr>
-              <a:t>Full recap - every cleaning decision, every chart, the chosen model.</a:t>
-            </a:r>
-          </a:p>
-        </p:txBody>
-      </p:sp>
-      <p:sp>
-        <p:nvSpPr>
-          <p:cNvPr id="19" name="TextBox 18"/>
-          <p:cNvSpPr txBox="1"/>
-          <p:nvPr/>
-        </p:nvSpPr>
-        <p:spPr>
-          <a:xfrm>
-            <a:off x="640080" y="6446520"/>
-            <a:ext cx="10881360" cy="320040"/>
-          </a:xfrm>
-          <a:prstGeom prst="rect">
-            <a:avLst/>
-          </a:prstGeom>
-          <a:noFill/>
-        </p:spPr>
-        <p:txBody>
-          <a:bodyPr wrap="square">
-            <a:spAutoFit/>
-          </a:bodyPr>
-          <a:lstStyle/>
-          <a:p>
-            <a:pPr algn="l">
-              <a:spcAft>
-                <a:spcPts val="600"/>
-              </a:spcAft>
-            </a:pPr>
-            <a:r>
-              <a:rPr sz="900" b="0" i="0">
-                <a:solidFill>
-                  <a:srgbClr val="635D6E"/>
-                </a:solidFill>
-                <a:latin typeface="Consolas"/>
-              </a:rPr>
-              <a:t>vybe-learn · web/api.py + app/agent</a:t>
+              <a:t>vybe-learn · app/intent + web/persona.py · docs/transfer-learning.md</a:t>
             </a:r>
           </a:p>
         </p:txBody>
@@ -9112,7 +10155,763 @@
                 </a:solidFill>
                 <a:latin typeface="Consolas"/>
               </a:rPr>
-              <a:t>06 — TECH STACK</a:t>
+              <a:t>06 — LEARNING PATH</a:t>
+            </a:r>
+          </a:p>
+        </p:txBody>
+      </p:sp>
+      <p:sp>
+        <p:nvSpPr>
+          <p:cNvPr id="3" name="TextBox 2"/>
+          <p:cNvSpPr txBox="1"/>
+          <p:nvPr/>
+        </p:nvSpPr>
+        <p:spPr>
+          <a:xfrm>
+            <a:off x="640080" y="777240"/>
+            <a:ext cx="10881360" cy="1005840"/>
+          </a:xfrm>
+          <a:prstGeom prst="rect">
+            <a:avLst/>
+          </a:prstGeom>
+          <a:noFill/>
+        </p:spPr>
+        <p:txBody>
+          <a:bodyPr wrap="square">
+            <a:spAutoFit/>
+          </a:bodyPr>
+          <a:lstStyle/>
+          <a:p>
+            <a:pPr algn="l">
+              <a:spcAft>
+                <a:spcPts val="600"/>
+              </a:spcAft>
+            </a:pPr>
+            <a:r>
+              <a:rPr sz="3200" b="1" i="0">
+                <a:solidFill>
+                  <a:srgbClr val="F4F2F7"/>
+                </a:solidFill>
+                <a:latin typeface="Georgia"/>
+              </a:rPr>
+              <a:t>Six stages, ten real steps</a:t>
+            </a:r>
+          </a:p>
+        </p:txBody>
+      </p:sp>
+      <p:sp>
+        <p:nvSpPr>
+          <p:cNvPr id="4" name="TextBox 3"/>
+          <p:cNvSpPr txBox="1"/>
+          <p:nvPr/>
+        </p:nvSpPr>
+        <p:spPr>
+          <a:xfrm>
+            <a:off x="640080" y="1417320"/>
+            <a:ext cx="10881360" cy="548640"/>
+          </a:xfrm>
+          <a:prstGeom prst="rect">
+            <a:avLst/>
+          </a:prstGeom>
+          <a:noFill/>
+        </p:spPr>
+        <p:txBody>
+          <a:bodyPr wrap="square">
+            <a:spAutoFit/>
+          </a:bodyPr>
+          <a:lstStyle/>
+          <a:p>
+            <a:pPr algn="l">
+              <a:spcAft>
+                <a:spcPts val="600"/>
+              </a:spcAft>
+            </a:pPr>
+            <a:r>
+              <a:rPr sz="1300" b="0" i="0">
+                <a:solidFill>
+                  <a:srgbClr val="948FA0"/>
+                </a:solidFill>
+                <a:latin typeface="Calibri"/>
+              </a:rPr>
+              <a:t>Verification is a bridging step between Cleaning and EDA - real, tested functionality, kept because it's the honest answer to “did the fix actually work?”</a:t>
+            </a:r>
+          </a:p>
+        </p:txBody>
+      </p:sp>
+      <p:sp>
+        <p:nvSpPr>
+          <p:cNvPr id="5" name="TextBox 4"/>
+          <p:cNvSpPr txBox="1"/>
+          <p:nvPr/>
+        </p:nvSpPr>
+        <p:spPr>
+          <a:xfrm>
+            <a:off x="640080" y="2057400"/>
+            <a:ext cx="457200" cy="576072"/>
+          </a:xfrm>
+          <a:prstGeom prst="rect">
+            <a:avLst/>
+          </a:prstGeom>
+          <a:noFill/>
+        </p:spPr>
+        <p:txBody>
+          <a:bodyPr wrap="square">
+            <a:spAutoFit/>
+          </a:bodyPr>
+          <a:lstStyle/>
+          <a:p>
+            <a:pPr algn="l">
+              <a:spcAft>
+                <a:spcPts val="600"/>
+              </a:spcAft>
+            </a:pPr>
+            <a:r>
+              <a:rPr sz="1200" b="0" i="0">
+                <a:solidFill>
+                  <a:srgbClr val="FF3EA5"/>
+                </a:solidFill>
+                <a:latin typeface="Consolas"/>
+              </a:rPr>
+              <a:t>01</a:t>
+            </a:r>
+          </a:p>
+        </p:txBody>
+      </p:sp>
+      <p:sp>
+        <p:nvSpPr>
+          <p:cNvPr id="6" name="TextBox 5"/>
+          <p:cNvSpPr txBox="1"/>
+          <p:nvPr/>
+        </p:nvSpPr>
+        <p:spPr>
+          <a:xfrm>
+            <a:off x="1188720" y="2057400"/>
+            <a:ext cx="10332720" cy="576072"/>
+          </a:xfrm>
+          <a:prstGeom prst="rect">
+            <a:avLst/>
+          </a:prstGeom>
+          <a:noFill/>
+        </p:spPr>
+        <p:txBody>
+          <a:bodyPr wrap="square">
+            <a:spAutoFit/>
+          </a:bodyPr>
+          <a:lstStyle/>
+          <a:p>
+            <a:r>
+              <a:rPr sz="1300" b="1" i="0">
+                <a:solidFill>
+                  <a:srgbClr val="F4F2F7"/>
+                </a:solidFill>
+                <a:latin typeface="Georgia"/>
+              </a:rPr>
+              <a:t>Python &amp; Data Fundamentals  </a:t>
+            </a:r>
+            <a:r>
+              <a:rPr sz="1100" b="0" i="0">
+                <a:solidFill>
+                  <a:srgbClr val="948FA0"/>
+                </a:solidFill>
+                <a:latin typeface="Calibri"/>
+              </a:rPr>
+              <a:t>Read a CSV, understand rows/columns, real pd.read_csv / df.shape / df.columns.</a:t>
+            </a:r>
+          </a:p>
+        </p:txBody>
+      </p:sp>
+      <p:sp>
+        <p:nvSpPr>
+          <p:cNvPr id="7" name="TextBox 6"/>
+          <p:cNvSpPr txBox="1"/>
+          <p:nvPr/>
+        </p:nvSpPr>
+        <p:spPr>
+          <a:xfrm>
+            <a:off x="640080" y="2633472"/>
+            <a:ext cx="457200" cy="576072"/>
+          </a:xfrm>
+          <a:prstGeom prst="rect">
+            <a:avLst/>
+          </a:prstGeom>
+          <a:noFill/>
+        </p:spPr>
+        <p:txBody>
+          <a:bodyPr wrap="square">
+            <a:spAutoFit/>
+          </a:bodyPr>
+          <a:lstStyle/>
+          <a:p>
+            <a:pPr algn="l">
+              <a:spcAft>
+                <a:spcPts val="600"/>
+              </a:spcAft>
+            </a:pPr>
+            <a:r>
+              <a:rPr sz="1200" b="0" i="0">
+                <a:solidFill>
+                  <a:srgbClr val="FF3EA5"/>
+                </a:solidFill>
+                <a:latin typeface="Consolas"/>
+              </a:rPr>
+              <a:t>02</a:t>
+            </a:r>
+          </a:p>
+        </p:txBody>
+      </p:sp>
+      <p:sp>
+        <p:nvSpPr>
+          <p:cNvPr id="8" name="TextBox 7"/>
+          <p:cNvSpPr txBox="1"/>
+          <p:nvPr/>
+        </p:nvSpPr>
+        <p:spPr>
+          <a:xfrm>
+            <a:off x="1188720" y="2633472"/>
+            <a:ext cx="10332720" cy="576072"/>
+          </a:xfrm>
+          <a:prstGeom prst="rect">
+            <a:avLst/>
+          </a:prstGeom>
+          <a:noFill/>
+        </p:spPr>
+        <p:txBody>
+          <a:bodyPr wrap="square">
+            <a:spAutoFit/>
+          </a:bodyPr>
+          <a:lstStyle/>
+          <a:p>
+            <a:r>
+              <a:rPr sz="1300" b="1" i="0">
+                <a:solidFill>
+                  <a:srgbClr val="F4F2F7"/>
+                </a:solidFill>
+                <a:latin typeface="Georgia"/>
+              </a:rPr>
+              <a:t>Data Cleaning  </a:t>
+            </a:r>
+            <a:r>
+              <a:rPr sz="1100" b="0" i="0">
+                <a:solidFill>
+                  <a:srgbClr val="948FA0"/>
+                </a:solidFill>
+                <a:latin typeface="Calibri"/>
+              </a:rPr>
+              <a:t>One level per detected issue. ⏭ “Skip cleaning” jumps straight to Verification.</a:t>
+            </a:r>
+          </a:p>
+        </p:txBody>
+      </p:sp>
+      <p:sp>
+        <p:nvSpPr>
+          <p:cNvPr id="9" name="TextBox 8"/>
+          <p:cNvSpPr txBox="1"/>
+          <p:nvPr/>
+        </p:nvSpPr>
+        <p:spPr>
+          <a:xfrm>
+            <a:off x="640080" y="3209544"/>
+            <a:ext cx="457200" cy="576072"/>
+          </a:xfrm>
+          <a:prstGeom prst="rect">
+            <a:avLst/>
+          </a:prstGeom>
+          <a:noFill/>
+        </p:spPr>
+        <p:txBody>
+          <a:bodyPr wrap="square">
+            <a:spAutoFit/>
+          </a:bodyPr>
+          <a:lstStyle/>
+          <a:p>
+            <a:pPr algn="l">
+              <a:spcAft>
+                <a:spcPts val="600"/>
+              </a:spcAft>
+            </a:pPr>
+            <a:r>
+              <a:rPr sz="1200" b="0" i="0">
+                <a:solidFill>
+                  <a:srgbClr val="FF3EA5"/>
+                </a:solidFill>
+                <a:latin typeface="Consolas"/>
+              </a:rPr>
+              <a:t>—</a:t>
+            </a:r>
+          </a:p>
+        </p:txBody>
+      </p:sp>
+      <p:sp>
+        <p:nvSpPr>
+          <p:cNvPr id="10" name="TextBox 9"/>
+          <p:cNvSpPr txBox="1"/>
+          <p:nvPr/>
+        </p:nvSpPr>
+        <p:spPr>
+          <a:xfrm>
+            <a:off x="1188720" y="3209544"/>
+            <a:ext cx="10332720" cy="576072"/>
+          </a:xfrm>
+          <a:prstGeom prst="rect">
+            <a:avLst/>
+          </a:prstGeom>
+          <a:noFill/>
+        </p:spPr>
+        <p:txBody>
+          <a:bodyPr wrap="square">
+            <a:spAutoFit/>
+          </a:bodyPr>
+          <a:lstStyle/>
+          <a:p>
+            <a:r>
+              <a:rPr sz="1300" b="1" i="0">
+                <a:solidFill>
+                  <a:srgbClr val="F4F2F7"/>
+                </a:solidFill>
+                <a:latin typeface="Georgia"/>
+              </a:rPr>
+              <a:t>Verification (bridge)  </a:t>
+            </a:r>
+            <a:r>
+              <a:rPr sz="1100" b="0" i="0">
+                <a:solidFill>
+                  <a:srgbClr val="948FA0"/>
+                </a:solidFill>
+                <a:latin typeface="Calibri"/>
+              </a:rPr>
+              <a:t>Real downstream tasks on cleaned data - aggregation, a bar chart, a trend line.</a:t>
+            </a:r>
+          </a:p>
+        </p:txBody>
+      </p:sp>
+      <p:sp>
+        <p:nvSpPr>
+          <p:cNvPr id="11" name="TextBox 10"/>
+          <p:cNvSpPr txBox="1"/>
+          <p:nvPr/>
+        </p:nvSpPr>
+        <p:spPr>
+          <a:xfrm>
+            <a:off x="640080" y="3785616"/>
+            <a:ext cx="457200" cy="576072"/>
+          </a:xfrm>
+          <a:prstGeom prst="rect">
+            <a:avLst/>
+          </a:prstGeom>
+          <a:noFill/>
+        </p:spPr>
+        <p:txBody>
+          <a:bodyPr wrap="square">
+            <a:spAutoFit/>
+          </a:bodyPr>
+          <a:lstStyle/>
+          <a:p>
+            <a:pPr algn="l">
+              <a:spcAft>
+                <a:spcPts val="600"/>
+              </a:spcAft>
+            </a:pPr>
+            <a:r>
+              <a:rPr sz="1200" b="0" i="0">
+                <a:solidFill>
+                  <a:srgbClr val="FF3EA5"/>
+                </a:solidFill>
+                <a:latin typeface="Consolas"/>
+              </a:rPr>
+              <a:t>03</a:t>
+            </a:r>
+          </a:p>
+        </p:txBody>
+      </p:sp>
+      <p:sp>
+        <p:nvSpPr>
+          <p:cNvPr id="12" name="TextBox 11"/>
+          <p:cNvSpPr txBox="1"/>
+          <p:nvPr/>
+        </p:nvSpPr>
+        <p:spPr>
+          <a:xfrm>
+            <a:off x="1188720" y="3785616"/>
+            <a:ext cx="10332720" cy="576072"/>
+          </a:xfrm>
+          <a:prstGeom prst="rect">
+            <a:avLst/>
+          </a:prstGeom>
+          <a:noFill/>
+        </p:spPr>
+        <p:txBody>
+          <a:bodyPr wrap="square">
+            <a:spAutoFit/>
+          </a:bodyPr>
+          <a:lstStyle/>
+          <a:p>
+            <a:r>
+              <a:rPr sz="1300" b="1" i="0">
+                <a:solidFill>
+                  <a:srgbClr val="F4F2F7"/>
+                </a:solidFill>
+                <a:latin typeface="Georgia"/>
+              </a:rPr>
+              <a:t>Exploratory Data Analysis  </a:t>
+            </a:r>
+            <a:r>
+              <a:rPr sz="1100" b="0" i="0">
+                <a:solidFill>
+                  <a:srgbClr val="948FA0"/>
+                </a:solidFill>
+                <a:latin typeface="Calibri"/>
+              </a:rPr>
+              <a:t>Real histograms, category bars, trend - plus a correlation card.</a:t>
+            </a:r>
+          </a:p>
+        </p:txBody>
+      </p:sp>
+      <p:sp>
+        <p:nvSpPr>
+          <p:cNvPr id="13" name="TextBox 12"/>
+          <p:cNvSpPr txBox="1"/>
+          <p:nvPr/>
+        </p:nvSpPr>
+        <p:spPr>
+          <a:xfrm>
+            <a:off x="640080" y="4361688"/>
+            <a:ext cx="457200" cy="576072"/>
+          </a:xfrm>
+          <a:prstGeom prst="rect">
+            <a:avLst/>
+          </a:prstGeom>
+          <a:noFill/>
+        </p:spPr>
+        <p:txBody>
+          <a:bodyPr wrap="square">
+            <a:spAutoFit/>
+          </a:bodyPr>
+          <a:lstStyle/>
+          <a:p>
+            <a:pPr algn="l">
+              <a:spcAft>
+                <a:spcPts val="600"/>
+              </a:spcAft>
+            </a:pPr>
+            <a:r>
+              <a:rPr sz="1200" b="0" i="0">
+                <a:solidFill>
+                  <a:srgbClr val="FF3EA5"/>
+                </a:solidFill>
+                <a:latin typeface="Consolas"/>
+              </a:rPr>
+              <a:t>04</a:t>
+            </a:r>
+          </a:p>
+        </p:txBody>
+      </p:sp>
+      <p:sp>
+        <p:nvSpPr>
+          <p:cNvPr id="14" name="TextBox 13"/>
+          <p:cNvSpPr txBox="1"/>
+          <p:nvPr/>
+        </p:nvSpPr>
+        <p:spPr>
+          <a:xfrm>
+            <a:off x="1188720" y="4361688"/>
+            <a:ext cx="10332720" cy="576072"/>
+          </a:xfrm>
+          <a:prstGeom prst="rect">
+            <a:avLst/>
+          </a:prstGeom>
+          <a:noFill/>
+        </p:spPr>
+        <p:txBody>
+          <a:bodyPr wrap="square">
+            <a:spAutoFit/>
+          </a:bodyPr>
+          <a:lstStyle/>
+          <a:p>
+            <a:r>
+              <a:rPr sz="1300" b="1" i="0">
+                <a:solidFill>
+                  <a:srgbClr val="F4F2F7"/>
+                </a:solidFill>
+                <a:latin typeface="Georgia"/>
+              </a:rPr>
+              <a:t>Machine Learning Foundations  </a:t>
+            </a:r>
+            <a:r>
+              <a:rPr sz="1100" b="0" i="0">
+                <a:solidFill>
+                  <a:srgbClr val="948FA0"/>
+                </a:solidFill>
+                <a:latin typeface="Calibri"/>
+              </a:rPr>
+              <a:t>Target, features, train/test split, regression vs. classification.</a:t>
+            </a:r>
+          </a:p>
+        </p:txBody>
+      </p:sp>
+      <p:sp>
+        <p:nvSpPr>
+          <p:cNvPr id="15" name="TextBox 14"/>
+          <p:cNvSpPr txBox="1"/>
+          <p:nvPr/>
+        </p:nvSpPr>
+        <p:spPr>
+          <a:xfrm>
+            <a:off x="640080" y="4937760"/>
+            <a:ext cx="457200" cy="576072"/>
+          </a:xfrm>
+          <a:prstGeom prst="rect">
+            <a:avLst/>
+          </a:prstGeom>
+          <a:noFill/>
+        </p:spPr>
+        <p:txBody>
+          <a:bodyPr wrap="square">
+            <a:spAutoFit/>
+          </a:bodyPr>
+          <a:lstStyle/>
+          <a:p>
+            <a:pPr algn="l">
+              <a:spcAft>
+                <a:spcPts val="600"/>
+              </a:spcAft>
+            </a:pPr>
+            <a:r>
+              <a:rPr sz="1200" b="0" i="0">
+                <a:solidFill>
+                  <a:srgbClr val="FF3EA5"/>
+                </a:solidFill>
+                <a:latin typeface="Consolas"/>
+              </a:rPr>
+              <a:t>05</a:t>
+            </a:r>
+          </a:p>
+        </p:txBody>
+      </p:sp>
+      <p:sp>
+        <p:nvSpPr>
+          <p:cNvPr id="16" name="TextBox 15"/>
+          <p:cNvSpPr txBox="1"/>
+          <p:nvPr/>
+        </p:nvSpPr>
+        <p:spPr>
+          <a:xfrm>
+            <a:off x="1188720" y="4937760"/>
+            <a:ext cx="10332720" cy="576072"/>
+          </a:xfrm>
+          <a:prstGeom prst="rect">
+            <a:avLst/>
+          </a:prstGeom>
+          <a:noFill/>
+        </p:spPr>
+        <p:txBody>
+          <a:bodyPr wrap="square">
+            <a:spAutoFit/>
+          </a:bodyPr>
+          <a:lstStyle/>
+          <a:p>
+            <a:r>
+              <a:rPr sz="1300" b="1" i="0">
+                <a:solidFill>
+                  <a:srgbClr val="F4F2F7"/>
+                </a:solidFill>
+                <a:latin typeface="Georgia"/>
+              </a:rPr>
+              <a:t>Model Selection &amp; Evaluation  </a:t>
+            </a:r>
+            <a:r>
+              <a:rPr sz="1100" b="0" i="0">
+                <a:solidFill>
+                  <a:srgbClr val="948FA0"/>
+                </a:solidFill>
+                <a:latin typeface="Calibri"/>
+              </a:rPr>
+              <a:t>The second agentic loop, narrated. ⏭ “Skip modeling” available.</a:t>
+            </a:r>
+          </a:p>
+        </p:txBody>
+      </p:sp>
+      <p:sp>
+        <p:nvSpPr>
+          <p:cNvPr id="17" name="TextBox 16"/>
+          <p:cNvSpPr txBox="1"/>
+          <p:nvPr/>
+        </p:nvSpPr>
+        <p:spPr>
+          <a:xfrm>
+            <a:off x="640080" y="5513832"/>
+            <a:ext cx="457200" cy="576072"/>
+          </a:xfrm>
+          <a:prstGeom prst="rect">
+            <a:avLst/>
+          </a:prstGeom>
+          <a:noFill/>
+        </p:spPr>
+        <p:txBody>
+          <a:bodyPr wrap="square">
+            <a:spAutoFit/>
+          </a:bodyPr>
+          <a:lstStyle/>
+          <a:p>
+            <a:pPr algn="l">
+              <a:spcAft>
+                <a:spcPts val="600"/>
+              </a:spcAft>
+            </a:pPr>
+            <a:r>
+              <a:rPr sz="1200" b="0" i="0">
+                <a:solidFill>
+                  <a:srgbClr val="FF3EA5"/>
+                </a:solidFill>
+                <a:latin typeface="Consolas"/>
+              </a:rPr>
+              <a:t>06</a:t>
+            </a:r>
+          </a:p>
+        </p:txBody>
+      </p:sp>
+      <p:sp>
+        <p:nvSpPr>
+          <p:cNvPr id="18" name="TextBox 17"/>
+          <p:cNvSpPr txBox="1"/>
+          <p:nvPr/>
+        </p:nvSpPr>
+        <p:spPr>
+          <a:xfrm>
+            <a:off x="1188720" y="5513832"/>
+            <a:ext cx="10332720" cy="576072"/>
+          </a:xfrm>
+          <a:prstGeom prst="rect">
+            <a:avLst/>
+          </a:prstGeom>
+          <a:noFill/>
+        </p:spPr>
+        <p:txBody>
+          <a:bodyPr wrap="square">
+            <a:spAutoFit/>
+          </a:bodyPr>
+          <a:lstStyle/>
+          <a:p>
+            <a:r>
+              <a:rPr sz="1300" b="1" i="0">
+                <a:solidFill>
+                  <a:srgbClr val="F4F2F7"/>
+                </a:solidFill>
+                <a:latin typeface="Georgia"/>
+              </a:rPr>
+              <a:t>Final Project  </a:t>
+            </a:r>
+            <a:r>
+              <a:rPr sz="1100" b="0" i="0">
+                <a:solidFill>
+                  <a:srgbClr val="948FA0"/>
+                </a:solidFill>
+                <a:latin typeface="Calibri"/>
+              </a:rPr>
+              <a:t>Full recap - every cleaning decision, every chart, the chosen model.</a:t>
+            </a:r>
+          </a:p>
+        </p:txBody>
+      </p:sp>
+      <p:sp>
+        <p:nvSpPr>
+          <p:cNvPr id="19" name="TextBox 18"/>
+          <p:cNvSpPr txBox="1"/>
+          <p:nvPr/>
+        </p:nvSpPr>
+        <p:spPr>
+          <a:xfrm>
+            <a:off x="640080" y="6446520"/>
+            <a:ext cx="10881360" cy="320040"/>
+          </a:xfrm>
+          <a:prstGeom prst="rect">
+            <a:avLst/>
+          </a:prstGeom>
+          <a:noFill/>
+        </p:spPr>
+        <p:txBody>
+          <a:bodyPr wrap="square">
+            <a:spAutoFit/>
+          </a:bodyPr>
+          <a:lstStyle/>
+          <a:p>
+            <a:pPr algn="l">
+              <a:spcAft>
+                <a:spcPts val="600"/>
+              </a:spcAft>
+            </a:pPr>
+            <a:r>
+              <a:rPr sz="900" b="0" i="0">
+                <a:solidFill>
+                  <a:srgbClr val="635D6E"/>
+                </a:solidFill>
+                <a:latin typeface="Consolas"/>
+              </a:rPr>
+              <a:t>vybe-learn · web/api.py + app/agent</a:t>
+            </a:r>
+          </a:p>
+        </p:txBody>
+      </p:sp>
+    </p:spTree>
+  </p:cSld>
+  <p:clrMapOvr>
+    <a:masterClrMapping/>
+  </p:clrMapOvr>
+</p:sld>
+</file>
+
+<file path=ppt/slides/slide9.xml><?xml version="1.0" encoding="utf-8"?>
+<p:sld xmlns:a="http://schemas.openxmlformats.org/drawingml/2006/main" xmlns:p="http://schemas.openxmlformats.org/presentationml/2006/main" xmlns:r="http://schemas.openxmlformats.org/officeDocument/2006/relationships">
+  <p:cSld>
+    <p:bg>
+      <p:bgPr>
+        <a:solidFill>
+          <a:srgbClr val="0B0A10"/>
+        </a:solidFill>
+        <a:effectLst/>
+      </p:bgPr>
+    </p:bg>
+    <p:spTree>
+      <p:nvGrpSpPr>
+        <p:cNvPr id="1" name=""/>
+        <p:cNvGrpSpPr/>
+        <p:nvPr/>
+      </p:nvGrpSpPr>
+      <p:grpSpPr/>
+      <p:sp>
+        <p:nvSpPr>
+          <p:cNvPr id="2" name="TextBox 1"/>
+          <p:cNvSpPr txBox="1"/>
+          <p:nvPr/>
+        </p:nvSpPr>
+        <p:spPr>
+          <a:xfrm>
+            <a:off x="640080" y="457200"/>
+            <a:ext cx="10881360" cy="365760"/>
+          </a:xfrm>
+          <a:prstGeom prst="rect">
+            <a:avLst/>
+          </a:prstGeom>
+          <a:noFill/>
+        </p:spPr>
+        <p:txBody>
+          <a:bodyPr wrap="square">
+            <a:spAutoFit/>
+          </a:bodyPr>
+          <a:lstStyle/>
+          <a:p>
+            <a:pPr algn="l">
+              <a:spcAft>
+                <a:spcPts val="600"/>
+              </a:spcAft>
+            </a:pPr>
+            <a:r>
+              <a:rPr sz="1300" b="1" i="0">
+                <a:solidFill>
+                  <a:srgbClr val="FF3EA5"/>
+                </a:solidFill>
+                <a:latin typeface="Consolas"/>
+              </a:rPr>
+              <a:t>07 — TECH STACK</a:t>
             </a:r>
           </a:p>
         </p:txBody>
@@ -10182,985 +11981,6 @@
 </p:sld>
 </file>
 
-<file path=ppt/slides/slide9.xml><?xml version="1.0" encoding="utf-8"?>
-<p:sld xmlns:a="http://schemas.openxmlformats.org/drawingml/2006/main" xmlns:p="http://schemas.openxmlformats.org/presentationml/2006/main" xmlns:r="http://schemas.openxmlformats.org/officeDocument/2006/relationships">
-  <p:cSld>
-    <p:bg>
-      <p:bgPr>
-        <a:solidFill>
-          <a:srgbClr val="0B0A10"/>
-        </a:solidFill>
-        <a:effectLst/>
-      </p:bgPr>
-    </p:bg>
-    <p:spTree>
-      <p:nvGrpSpPr>
-        <p:cNvPr id="1" name=""/>
-        <p:cNvGrpSpPr/>
-        <p:nvPr/>
-      </p:nvGrpSpPr>
-      <p:grpSpPr/>
-      <p:sp>
-        <p:nvSpPr>
-          <p:cNvPr id="2" name="TextBox 1"/>
-          <p:cNvSpPr txBox="1"/>
-          <p:nvPr/>
-        </p:nvSpPr>
-        <p:spPr>
-          <a:xfrm>
-            <a:off x="640080" y="457200"/>
-            <a:ext cx="10881360" cy="365760"/>
-          </a:xfrm>
-          <a:prstGeom prst="rect">
-            <a:avLst/>
-          </a:prstGeom>
-          <a:noFill/>
-        </p:spPr>
-        <p:txBody>
-          <a:bodyPr wrap="square">
-            <a:spAutoFit/>
-          </a:bodyPr>
-          <a:lstStyle/>
-          <a:p>
-            <a:pPr algn="l">
-              <a:spcAft>
-                <a:spcPts val="600"/>
-              </a:spcAft>
-            </a:pPr>
-            <a:r>
-              <a:rPr sz="1300" b="1" i="0">
-                <a:solidFill>
-                  <a:srgbClr val="FF3EA5"/>
-                </a:solidFill>
-                <a:latin typeface="Consolas"/>
-              </a:rPr>
-              <a:t>07 — THE CASE</a:t>
-            </a:r>
-          </a:p>
-        </p:txBody>
-      </p:sp>
-      <p:sp>
-        <p:nvSpPr>
-          <p:cNvPr id="3" name="TextBox 2"/>
-          <p:cNvSpPr txBox="1"/>
-          <p:nvPr/>
-        </p:nvSpPr>
-        <p:spPr>
-          <a:xfrm>
-            <a:off x="640080" y="777240"/>
-            <a:ext cx="10881360" cy="1005840"/>
-          </a:xfrm>
-          <a:prstGeom prst="rect">
-            <a:avLst/>
-          </a:prstGeom>
-          <a:noFill/>
-        </p:spPr>
-        <p:txBody>
-          <a:bodyPr wrap="square">
-            <a:spAutoFit/>
-          </a:bodyPr>
-          <a:lstStyle/>
-          <a:p>
-            <a:pPr algn="l">
-              <a:spcAft>
-                <a:spcPts val="600"/>
-              </a:spcAft>
-            </a:pPr>
-            <a:r>
-              <a:rPr sz="3200" b="1" i="0">
-                <a:solidFill>
-                  <a:srgbClr val="F4F2F7"/>
-                </a:solidFill>
-                <a:latin typeface="Georgia"/>
-              </a:rPr>
-              <a:t>Why this beats a chatbot wrapper</a:t>
-            </a:r>
-          </a:p>
-        </p:txBody>
-      </p:sp>
-      <p:graphicFrame>
-        <p:nvGraphicFramePr>
-          <p:cNvPr id="4" name="Table 3"/>
-          <p:cNvGraphicFramePr>
-            <a:graphicFrameLocks noGrp="1"/>
-          </p:cNvGraphicFramePr>
-          <p:nvPr/>
-        </p:nvGraphicFramePr>
-        <p:xfrm>
-          <a:off x="640080" y="1463040"/>
-          <a:ext cx="10881360" cy="3291840"/>
-        </p:xfrm>
-        <a:graphic>
-          <a:graphicData uri="http://schemas.openxmlformats.org/drawingml/2006/table">
-            <a:tbl>
-              <a:tblPr firstRow="1" bandRow="1">
-                <a:tableStyleId>{5C22544A-7EE6-4342-B048-85BDC9FD1C3A}</a:tableStyleId>
-              </a:tblPr>
-              <a:tblGrid>
-                <a:gridCol w="2834640"/>
-                <a:gridCol w="4023360"/>
-                <a:gridCol w="4023360"/>
-              </a:tblGrid>
-              <a:tr h="470262">
-                <a:tc>
-                  <a:txBody>
-                    <a:bodyPr wrap="square"/>
-                    <a:lstStyle/>
-                    <a:p>
-                      <a:r>
-                        <a:rPr sz="1000" b="1" i="0">
-                          <a:solidFill>
-                            <a:srgbClr val="635D6E"/>
-                          </a:solidFill>
-                          <a:latin typeface="Consolas"/>
-                        </a:rPr>
-                        <a:t>Axis</a:t>
-                      </a:r>
-                    </a:p>
-                  </a:txBody>
-                  <a:tcPr marL="109728" anchor="ctr">
-                    <a:solidFill>
-                      <a:srgbClr val="1D1A25"/>
-                    </a:solidFill>
-                  </a:tcPr>
-                </a:tc>
-                <a:tc>
-                  <a:txBody>
-                    <a:bodyPr wrap="square"/>
-                    <a:lstStyle/>
-                    <a:p>
-                      <a:r>
-                        <a:rPr sz="1000" b="1" i="0">
-                          <a:solidFill>
-                            <a:srgbClr val="635D6E"/>
-                          </a:solidFill>
-                          <a:latin typeface="Consolas"/>
-                        </a:rPr>
-                        <a:t>Typical AI-tutor demo</a:t>
-                      </a:r>
-                    </a:p>
-                  </a:txBody>
-                  <a:tcPr marL="109728" anchor="ctr">
-                    <a:solidFill>
-                      <a:srgbClr val="1D1A25"/>
-                    </a:solidFill>
-                  </a:tcPr>
-                </a:tc>
-                <a:tc>
-                  <a:txBody>
-                    <a:bodyPr wrap="square"/>
-                    <a:lstStyle/>
-                    <a:p>
-                      <a:r>
-                        <a:rPr sz="1000" b="1" i="0">
-                          <a:solidFill>
-                            <a:srgbClr val="635D6E"/>
-                          </a:solidFill>
-                          <a:latin typeface="Consolas"/>
-                        </a:rPr>
-                        <a:t>VYBE Learn</a:t>
-                      </a:r>
-                    </a:p>
-                  </a:txBody>
-                  <a:tcPr marL="109728" anchor="ctr">
-                    <a:solidFill>
-                      <a:srgbClr val="1D1A25"/>
-                    </a:solidFill>
-                  </a:tcPr>
-                </a:tc>
-              </a:tr>
-              <a:tr h="470262">
-                <a:tc>
-                  <a:txBody>
-                    <a:bodyPr wrap="square"/>
-                    <a:lstStyle/>
-                    <a:p>
-                      <a:r>
-                        <a:rPr sz="1100" b="0" i="0">
-                          <a:solidFill>
-                            <a:srgbClr val="F4F2F7"/>
-                          </a:solidFill>
-                          <a:latin typeface="Calibri"/>
-                        </a:rPr>
-                        <a:t>Who decides the fix</a:t>
-                      </a:r>
-                    </a:p>
-                  </a:txBody>
-                  <a:tcPr marL="109728" anchor="ctr">
-                    <a:solidFill>
-                      <a:srgbClr val="16141C"/>
-                    </a:solidFill>
-                  </a:tcPr>
-                </a:tc>
-                <a:tc>
-                  <a:txBody>
-                    <a:bodyPr wrap="square"/>
-                    <a:lstStyle/>
-                    <a:p>
-                      <a:r>
-                        <a:rPr sz="1100" b="0" i="0">
-                          <a:solidFill>
-                            <a:srgbClr val="FF6B7A"/>
-                          </a:solidFill>
-                          <a:latin typeface="Calibri"/>
-                        </a:rPr>
-                        <a:t>✗  the LLM guesses in-context</a:t>
-                      </a:r>
-                    </a:p>
-                  </a:txBody>
-                  <a:tcPr marL="109728" anchor="ctr">
-                    <a:solidFill>
-                      <a:srgbClr val="16141C"/>
-                    </a:solidFill>
-                  </a:tcPr>
-                </a:tc>
-                <a:tc>
-                  <a:txBody>
-                    <a:bodyPr wrap="square"/>
-                    <a:lstStyle/>
-                    <a:p>
-                      <a:r>
-                        <a:rPr sz="1100" b="0" i="0">
-                          <a:solidFill>
-                            <a:srgbClr val="3DDC8A"/>
-                          </a:solidFill>
-                          <a:latin typeface="Calibri"/>
-                        </a:rPr>
-                        <a:t>✓  a deterministic loop, measured and re-checked</a:t>
-                      </a:r>
-                    </a:p>
-                  </a:txBody>
-                  <a:tcPr marL="109728" anchor="ctr">
-                    <a:solidFill>
-                      <a:srgbClr val="16141C"/>
-                    </a:solidFill>
-                  </a:tcPr>
-                </a:tc>
-              </a:tr>
-              <a:tr h="470262">
-                <a:tc>
-                  <a:txBody>
-                    <a:bodyPr wrap="square"/>
-                    <a:lstStyle/>
-                    <a:p>
-                      <a:r>
-                        <a:rPr sz="1100" b="0" i="0">
-                          <a:solidFill>
-                            <a:srgbClr val="F4F2F7"/>
-                          </a:solidFill>
-                          <a:latin typeface="Calibri"/>
-                        </a:rPr>
-                        <a:t>Why a fix was kept</a:t>
-                      </a:r>
-                    </a:p>
-                  </a:txBody>
-                  <a:tcPr marL="109728" anchor="ctr">
-                    <a:solidFill>
-                      <a:srgbClr val="16141C"/>
-                    </a:solidFill>
-                  </a:tcPr>
-                </a:tc>
-                <a:tc>
-                  <a:txBody>
-                    <a:bodyPr wrap="square"/>
-                    <a:lstStyle/>
-                    <a:p>
-                      <a:r>
-                        <a:rPr sz="1100" b="0" i="0">
-                          <a:solidFill>
-                            <a:srgbClr val="FF6B7A"/>
-                          </a:solidFill>
-                          <a:latin typeface="Calibri"/>
-                        </a:rPr>
-                        <a:t>✗  a plausible-sounding sentence</a:t>
-                      </a:r>
-                    </a:p>
-                  </a:txBody>
-                  <a:tcPr marL="109728" anchor="ctr">
-                    <a:solidFill>
-                      <a:srgbClr val="16141C"/>
-                    </a:solidFill>
-                  </a:tcPr>
-                </a:tc>
-                <a:tc>
-                  <a:txBody>
-                    <a:bodyPr wrap="square"/>
-                    <a:lstStyle/>
-                    <a:p>
-                      <a:r>
-                        <a:rPr sz="1100" b="0" i="0">
-                          <a:solidFill>
-                            <a:srgbClr val="3DDC8A"/>
-                          </a:solidFill>
-                          <a:latin typeface="Calibri"/>
-                        </a:rPr>
-                        <a:t>✓  a real skew-shift number against a stated threshold</a:t>
-                      </a:r>
-                    </a:p>
-                  </a:txBody>
-                  <a:tcPr marL="109728" anchor="ctr">
-                    <a:solidFill>
-                      <a:srgbClr val="16141C"/>
-                    </a:solidFill>
-                  </a:tcPr>
-                </a:tc>
-              </a:tr>
-              <a:tr h="470262">
-                <a:tc>
-                  <a:txBody>
-                    <a:bodyPr wrap="square"/>
-                    <a:lstStyle/>
-                    <a:p>
-                      <a:r>
-                        <a:rPr sz="1100" b="0" i="0">
-                          <a:solidFill>
-                            <a:srgbClr val="F4F2F7"/>
-                          </a:solidFill>
-                          <a:latin typeface="Calibri"/>
-                        </a:rPr>
-                        <a:t>When the model breaks</a:t>
-                      </a:r>
-                    </a:p>
-                  </a:txBody>
-                  <a:tcPr marL="109728" anchor="ctr">
-                    <a:solidFill>
-                      <a:srgbClr val="16141C"/>
-                    </a:solidFill>
-                  </a:tcPr>
-                </a:tc>
-                <a:tc>
-                  <a:txBody>
-                    <a:bodyPr wrap="square"/>
-                    <a:lstStyle/>
-                    <a:p>
-                      <a:r>
-                        <a:rPr sz="1100" b="0" i="0">
-                          <a:solidFill>
-                            <a:srgbClr val="FF6B7A"/>
-                          </a:solidFill>
-                          <a:latin typeface="Calibri"/>
-                        </a:rPr>
-                        <a:t>✗  stalls, apologizes, or hallucinates</a:t>
-                      </a:r>
-                    </a:p>
-                  </a:txBody>
-                  <a:tcPr marL="109728" anchor="ctr">
-                    <a:solidFill>
-                      <a:srgbClr val="16141C"/>
-                    </a:solidFill>
-                  </a:tcPr>
-                </a:tc>
-                <a:tc>
-                  <a:txBody>
-                    <a:bodyPr wrap="square"/>
-                    <a:lstStyle/>
-                    <a:p>
-                      <a:r>
-                        <a:rPr sz="1100" b="0" i="0">
-                          <a:solidFill>
-                            <a:srgbClr val="3DDC8A"/>
-                          </a:solidFill>
-                          <a:latin typeface="Calibri"/>
-                        </a:rPr>
-                        <a:t>✓  falls through ADK → Gemini → FAQ, discloses which</a:t>
-                      </a:r>
-                    </a:p>
-                  </a:txBody>
-                  <a:tcPr marL="109728" anchor="ctr">
-                    <a:solidFill>
-                      <a:srgbClr val="16141C"/>
-                    </a:solidFill>
-                  </a:tcPr>
-                </a:tc>
-              </a:tr>
-              <a:tr h="470262">
-                <a:tc>
-                  <a:txBody>
-                    <a:bodyPr wrap="square"/>
-                    <a:lstStyle/>
-                    <a:p>
-                      <a:r>
-                        <a:rPr sz="1100" b="0" i="0">
-                          <a:solidFill>
-                            <a:srgbClr val="F4F2F7"/>
-                          </a:solidFill>
-                          <a:latin typeface="Calibri"/>
-                        </a:rPr>
-                        <a:t>Personalization</a:t>
-                      </a:r>
-                    </a:p>
-                  </a:txBody>
-                  <a:tcPr marL="109728" anchor="ctr">
-                    <a:solidFill>
-                      <a:srgbClr val="16141C"/>
-                    </a:solidFill>
-                  </a:tcPr>
-                </a:tc>
-                <a:tc>
-                  <a:txBody>
-                    <a:bodyPr wrap="square"/>
-                    <a:lstStyle/>
-                    <a:p>
-                      <a:r>
-                        <a:rPr sz="1100" b="0" i="0">
-                          <a:solidFill>
-                            <a:srgbClr val="FF6B7A"/>
-                          </a:solidFill>
-                          <a:latin typeface="Calibri"/>
-                        </a:rPr>
-                        <a:t>✗  one-size tone knob</a:t>
-                      </a:r>
-                    </a:p>
-                  </a:txBody>
-                  <a:tcPr marL="109728" anchor="ctr">
-                    <a:solidFill>
-                      <a:srgbClr val="16141C"/>
-                    </a:solidFill>
-                  </a:tcPr>
-                </a:tc>
-                <a:tc>
-                  <a:txBody>
-                    <a:bodyPr wrap="square"/>
-                    <a:lstStyle/>
-                    <a:p>
-                      <a:r>
-                        <a:rPr sz="1100" b="0" i="0">
-                          <a:solidFill>
-                            <a:srgbClr val="3DDC8A"/>
-                          </a:solidFill>
-                          <a:latin typeface="Calibri"/>
-                        </a:rPr>
-                        <a:t>✓  3 modes, driven by real hint/attempt counters</a:t>
-                      </a:r>
-                    </a:p>
-                  </a:txBody>
-                  <a:tcPr marL="109728" anchor="ctr">
-                    <a:solidFill>
-                      <a:srgbClr val="16141C"/>
-                    </a:solidFill>
-                  </a:tcPr>
-                </a:tc>
-              </a:tr>
-              <a:tr h="470262">
-                <a:tc>
-                  <a:txBody>
-                    <a:bodyPr wrap="square"/>
-                    <a:lstStyle/>
-                    <a:p>
-                      <a:r>
-                        <a:rPr sz="1100" b="0" i="0">
-                          <a:solidFill>
-                            <a:srgbClr val="F4F2F7"/>
-                          </a:solidFill>
-                          <a:latin typeface="Calibri"/>
-                        </a:rPr>
-                        <a:t>Cheats the learner?</a:t>
-                      </a:r>
-                    </a:p>
-                  </a:txBody>
-                  <a:tcPr marL="109728" anchor="ctr">
-                    <a:solidFill>
-                      <a:srgbClr val="16141C"/>
-                    </a:solidFill>
-                  </a:tcPr>
-                </a:tc>
-                <a:tc>
-                  <a:txBody>
-                    <a:bodyPr wrap="square"/>
-                    <a:lstStyle/>
-                    <a:p>
-                      <a:r>
-                        <a:rPr sz="1100" b="0" i="0">
-                          <a:solidFill>
-                            <a:srgbClr val="FF6B7A"/>
-                          </a:solidFill>
-                          <a:latin typeface="Calibri"/>
-                        </a:rPr>
-                        <a:t>✗  answers before they've tried</a:t>
-                      </a:r>
-                    </a:p>
-                  </a:txBody>
-                  <a:tcPr marL="109728" anchor="ctr">
-                    <a:solidFill>
-                      <a:srgbClr val="16141C"/>
-                    </a:solidFill>
-                  </a:tcPr>
-                </a:tc>
-                <a:tc>
-                  <a:txBody>
-                    <a:bodyPr wrap="square"/>
-                    <a:lstStyle/>
-                    <a:p>
-                      <a:r>
-                        <a:rPr sz="1100" b="0" i="0">
-                          <a:solidFill>
-                            <a:srgbClr val="3DDC8A"/>
-                          </a:solidFill>
-                          <a:latin typeface="Calibri"/>
-                        </a:rPr>
-                        <a:t>✓  nudges only, reveal gated on attempt history</a:t>
-                      </a:r>
-                    </a:p>
-                  </a:txBody>
-                  <a:tcPr marL="109728" anchor="ctr">
-                    <a:solidFill>
-                      <a:srgbClr val="16141C"/>
-                    </a:solidFill>
-                  </a:tcPr>
-                </a:tc>
-              </a:tr>
-              <a:tr h="470268">
-                <a:tc>
-                  <a:txBody>
-                    <a:bodyPr wrap="square"/>
-                    <a:lstStyle/>
-                    <a:p>
-                      <a:r>
-                        <a:rPr sz="1100" b="0" i="0">
-                          <a:solidFill>
-                            <a:srgbClr val="F4F2F7"/>
-                          </a:solidFill>
-                          <a:latin typeface="Calibri"/>
-                        </a:rPr>
-                        <a:t>Respects prior knowledge</a:t>
-                      </a:r>
-                    </a:p>
-                  </a:txBody>
-                  <a:tcPr marL="109728" anchor="ctr">
-                    <a:solidFill>
-                      <a:srgbClr val="16141C"/>
-                    </a:solidFill>
-                  </a:tcPr>
-                </a:tc>
-                <a:tc>
-                  <a:txBody>
-                    <a:bodyPr wrap="square"/>
-                    <a:lstStyle/>
-                    <a:p>
-                      <a:r>
-                        <a:rPr sz="1100" b="0" i="0">
-                          <a:solidFill>
-                            <a:srgbClr val="FF6B7A"/>
-                          </a:solidFill>
-                          <a:latin typeface="Calibri"/>
-                        </a:rPr>
-                        <a:t>✗  forces every learner through every step</a:t>
-                      </a:r>
-                    </a:p>
-                  </a:txBody>
-                  <a:tcPr marL="109728" anchor="ctr">
-                    <a:solidFill>
-                      <a:srgbClr val="16141C"/>
-                    </a:solidFill>
-                  </a:tcPr>
-                </a:tc>
-                <a:tc>
-                  <a:txBody>
-                    <a:bodyPr wrap="square"/>
-                    <a:lstStyle/>
-                    <a:p>
-                      <a:r>
-                        <a:rPr sz="1100" b="0" i="0">
-                          <a:solidFill>
-                            <a:srgbClr val="3DDC8A"/>
-                          </a:solidFill>
-                          <a:latin typeface="Calibri"/>
-                        </a:rPr>
-                        <a:t>✓  explicit Skip actions, no faked checkmarks</a:t>
-                      </a:r>
-                    </a:p>
-                  </a:txBody>
-                  <a:tcPr marL="109728" anchor="ctr">
-                    <a:solidFill>
-                      <a:srgbClr val="16141C"/>
-                    </a:solidFill>
-                  </a:tcPr>
-                </a:tc>
-              </a:tr>
-            </a:tbl>
-          </a:graphicData>
-        </a:graphic>
-      </p:graphicFrame>
-      <p:sp>
-        <p:nvSpPr>
-          <p:cNvPr id="5" name="Rounded Rectangle 4"/>
-          <p:cNvSpPr/>
-          <p:nvPr/>
-        </p:nvSpPr>
-        <p:spPr>
-          <a:xfrm>
-            <a:off x="640080" y="4983480"/>
-            <a:ext cx="2615184" cy="1325880"/>
-          </a:xfrm>
-          <a:prstGeom prst="roundRect">
-            <a:avLst>
-              <a:gd name="adj" fmla="val 6000"/>
-            </a:avLst>
-          </a:prstGeom>
-          <a:solidFill>
-            <a:srgbClr val="16141C"/>
-          </a:solidFill>
-          <a:ln w="12700">
-            <a:solidFill>
-              <a:srgbClr val="28242F"/>
-            </a:solidFill>
-          </a:ln>
-          <a:effectLst/>
-        </p:spPr>
-        <p:style>
-          <a:lnRef idx="1">
-            <a:schemeClr val="accent1"/>
-          </a:lnRef>
-          <a:fillRef idx="3">
-            <a:schemeClr val="accent1"/>
-          </a:fillRef>
-          <a:effectRef idx="2">
-            <a:schemeClr val="accent1"/>
-          </a:effectRef>
-          <a:fontRef idx="minor">
-            <a:schemeClr val="lt1"/>
-          </a:fontRef>
-        </p:style>
-        <p:txBody>
-          <a:bodyPr rtlCol="0" anchor="ctr" wrap="square" lIns="137160" tIns="91440"/>
-          <a:lstStyle/>
-          <a:p>
-            <a:pPr algn="l">
-              <a:spcAft>
-                <a:spcPts val="300"/>
-              </a:spcAft>
-            </a:pPr>
-            <a:r>
-              <a:rPr sz="1600" b="1" i="0">
-                <a:solidFill>
-                  <a:srgbClr val="FF3EA5"/>
-                </a:solidFill>
-                <a:latin typeface="Consolas"/>
-              </a:rPr>
-              <a:t>01</a:t>
-            </a:r>
-          </a:p>
-          <a:p>
-            <a:pPr algn="l">
-              <a:spcAft>
-                <a:spcPts val="300"/>
-              </a:spcAft>
-            </a:pPr>
-            <a:r>
-              <a:rPr sz="1200" b="1" i="0">
-                <a:solidFill>
-                  <a:srgbClr val="F4F2F7"/>
-                </a:solidFill>
-                <a:latin typeface="Georgia"/>
-              </a:rPr>
-              <a:t>Technical depth</a:t>
-            </a:r>
-          </a:p>
-          <a:p>
-            <a:pPr algn="l">
-              <a:spcAft>
-                <a:spcPts val="0"/>
-              </a:spcAft>
-            </a:pPr>
-            <a:r>
-              <a:rPr sz="950" b="0" i="0">
-                <a:solidFill>
-                  <a:srgbClr val="948FA0"/>
-                </a:solidFill>
-                <a:latin typeface="Calibri"/>
-              </a:rPr>
-              <a:t>Two independent agentic loops with real statistical acceptance criteria.</a:t>
-            </a:r>
-          </a:p>
-        </p:txBody>
-      </p:sp>
-      <p:sp>
-        <p:nvSpPr>
-          <p:cNvPr id="6" name="Rounded Rectangle 5"/>
-          <p:cNvSpPr/>
-          <p:nvPr/>
-        </p:nvSpPr>
-        <p:spPr>
-          <a:xfrm>
-            <a:off x="3346704" y="4983480"/>
-            <a:ext cx="2615184" cy="1325880"/>
-          </a:xfrm>
-          <a:prstGeom prst="roundRect">
-            <a:avLst>
-              <a:gd name="adj" fmla="val 6000"/>
-            </a:avLst>
-          </a:prstGeom>
-          <a:solidFill>
-            <a:srgbClr val="16141C"/>
-          </a:solidFill>
-          <a:ln w="12700">
-            <a:solidFill>
-              <a:srgbClr val="28242F"/>
-            </a:solidFill>
-          </a:ln>
-          <a:effectLst/>
-        </p:spPr>
-        <p:style>
-          <a:lnRef idx="1">
-            <a:schemeClr val="accent1"/>
-          </a:lnRef>
-          <a:fillRef idx="3">
-            <a:schemeClr val="accent1"/>
-          </a:fillRef>
-          <a:effectRef idx="2">
-            <a:schemeClr val="accent1"/>
-          </a:effectRef>
-          <a:fontRef idx="minor">
-            <a:schemeClr val="lt1"/>
-          </a:fontRef>
-        </p:style>
-        <p:txBody>
-          <a:bodyPr rtlCol="0" anchor="ctr" wrap="square" lIns="137160" tIns="91440"/>
-          <a:lstStyle/>
-          <a:p>
-            <a:pPr algn="l">
-              <a:spcAft>
-                <a:spcPts val="300"/>
-              </a:spcAft>
-            </a:pPr>
-            <a:r>
-              <a:rPr sz="1600" b="1" i="0">
-                <a:solidFill>
-                  <a:srgbClr val="FF3EA5"/>
-                </a:solidFill>
-                <a:latin typeface="Consolas"/>
-              </a:rPr>
-              <a:t>02</a:t>
-            </a:r>
-          </a:p>
-          <a:p>
-            <a:pPr algn="l">
-              <a:spcAft>
-                <a:spcPts val="300"/>
-              </a:spcAft>
-            </a:pPr>
-            <a:r>
-              <a:rPr sz="1200" b="1" i="0">
-                <a:solidFill>
-                  <a:srgbClr val="F4F2F7"/>
-                </a:solidFill>
-                <a:latin typeface="Georgia"/>
-              </a:rPr>
-              <a:t>Reliability under judging</a:t>
-            </a:r>
-          </a:p>
-          <a:p>
-            <a:pPr algn="l">
-              <a:spcAft>
-                <a:spcPts val="0"/>
-              </a:spcAft>
-            </a:pPr>
-            <a:r>
-              <a:rPr sz="950" b="0" i="0">
-                <a:solidFill>
-                  <a:srgbClr val="948FA0"/>
-                </a:solidFill>
-                <a:latin typeface="Calibri"/>
-              </a:rPr>
-              <a:t>3-tier fallback: bad wifi or a dead key degrades the tutor, never crashes the demo.</a:t>
-            </a:r>
-          </a:p>
-        </p:txBody>
-      </p:sp>
-      <p:sp>
-        <p:nvSpPr>
-          <p:cNvPr id="7" name="Rounded Rectangle 6"/>
-          <p:cNvSpPr/>
-          <p:nvPr/>
-        </p:nvSpPr>
-        <p:spPr>
-          <a:xfrm>
-            <a:off x="6053328" y="4983480"/>
-            <a:ext cx="2615184" cy="1325880"/>
-          </a:xfrm>
-          <a:prstGeom prst="roundRect">
-            <a:avLst>
-              <a:gd name="adj" fmla="val 6000"/>
-            </a:avLst>
-          </a:prstGeom>
-          <a:solidFill>
-            <a:srgbClr val="16141C"/>
-          </a:solidFill>
-          <a:ln w="12700">
-            <a:solidFill>
-              <a:srgbClr val="28242F"/>
-            </a:solidFill>
-          </a:ln>
-          <a:effectLst/>
-        </p:spPr>
-        <p:style>
-          <a:lnRef idx="1">
-            <a:schemeClr val="accent1"/>
-          </a:lnRef>
-          <a:fillRef idx="3">
-            <a:schemeClr val="accent1"/>
-          </a:fillRef>
-          <a:effectRef idx="2">
-            <a:schemeClr val="accent1"/>
-          </a:effectRef>
-          <a:fontRef idx="minor">
-            <a:schemeClr val="lt1"/>
-          </a:fontRef>
-        </p:style>
-        <p:txBody>
-          <a:bodyPr rtlCol="0" anchor="ctr" wrap="square" lIns="137160" tIns="91440"/>
-          <a:lstStyle/>
-          <a:p>
-            <a:pPr algn="l">
-              <a:spcAft>
-                <a:spcPts val="300"/>
-              </a:spcAft>
-            </a:pPr>
-            <a:r>
-              <a:rPr sz="1600" b="1" i="0">
-                <a:solidFill>
-                  <a:srgbClr val="FF3EA5"/>
-                </a:solidFill>
-                <a:latin typeface="Consolas"/>
-              </a:rPr>
-              <a:t>03</a:t>
-            </a:r>
-          </a:p>
-          <a:p>
-            <a:pPr algn="l">
-              <a:spcAft>
-                <a:spcPts val="300"/>
-              </a:spcAft>
-            </a:pPr>
-            <a:r>
-              <a:rPr sz="1200" b="1" i="0">
-                <a:solidFill>
-                  <a:srgbClr val="F4F2F7"/>
-                </a:solidFill>
-                <a:latin typeface="Georgia"/>
-              </a:rPr>
-              <a:t>Genuine UX craft</a:t>
-            </a:r>
-          </a:p>
-          <a:p>
-            <a:pPr algn="l">
-              <a:spcAft>
-                <a:spcPts val="0"/>
-              </a:spcAft>
-            </a:pPr>
-            <a:r>
-              <a:rPr sz="950" b="0" i="0">
-                <a:solidFill>
-                  <a:srgbClr val="948FA0"/>
-                </a:solidFill>
-                <a:latin typeface="Calibri"/>
-              </a:rPr>
-              <a:t>Gamified scoring, progress rail, mentor panel, notes - none blocking the core loop.</a:t>
-            </a:r>
-          </a:p>
-        </p:txBody>
-      </p:sp>
-      <p:sp>
-        <p:nvSpPr>
-          <p:cNvPr id="8" name="Rounded Rectangle 7"/>
-          <p:cNvSpPr/>
-          <p:nvPr/>
-        </p:nvSpPr>
-        <p:spPr>
-          <a:xfrm>
-            <a:off x="8759952" y="4983480"/>
-            <a:ext cx="2615184" cy="1325880"/>
-          </a:xfrm>
-          <a:prstGeom prst="roundRect">
-            <a:avLst>
-              <a:gd name="adj" fmla="val 6000"/>
-            </a:avLst>
-          </a:prstGeom>
-          <a:solidFill>
-            <a:srgbClr val="16141C"/>
-          </a:solidFill>
-          <a:ln w="12700">
-            <a:solidFill>
-              <a:srgbClr val="28242F"/>
-            </a:solidFill>
-          </a:ln>
-          <a:effectLst/>
-        </p:spPr>
-        <p:style>
-          <a:lnRef idx="1">
-            <a:schemeClr val="accent1"/>
-          </a:lnRef>
-          <a:fillRef idx="3">
-            <a:schemeClr val="accent1"/>
-          </a:fillRef>
-          <a:effectRef idx="2">
-            <a:schemeClr val="accent1"/>
-          </a:effectRef>
-          <a:fontRef idx="minor">
-            <a:schemeClr val="lt1"/>
-          </a:fontRef>
-        </p:style>
-        <p:txBody>
-          <a:bodyPr rtlCol="0" anchor="ctr" wrap="square" lIns="137160" tIns="91440"/>
-          <a:lstStyle/>
-          <a:p>
-            <a:pPr algn="l">
-              <a:spcAft>
-                <a:spcPts val="300"/>
-              </a:spcAft>
-            </a:pPr>
-            <a:r>
-              <a:rPr sz="1600" b="1" i="0">
-                <a:solidFill>
-                  <a:srgbClr val="FF3EA5"/>
-                </a:solidFill>
-                <a:latin typeface="Consolas"/>
-              </a:rPr>
-              <a:t>04</a:t>
-            </a:r>
-          </a:p>
-          <a:p>
-            <a:pPr algn="l">
-              <a:spcAft>
-                <a:spcPts val="300"/>
-              </a:spcAft>
-            </a:pPr>
-            <a:r>
-              <a:rPr sz="1200" b="1" i="0">
-                <a:solidFill>
-                  <a:srgbClr val="F4F2F7"/>
-                </a:solidFill>
-                <a:latin typeface="Georgia"/>
-              </a:rPr>
-              <a:t>Works on their data</a:t>
-            </a:r>
-          </a:p>
-          <a:p>
-            <a:pPr algn="l">
-              <a:spcAft>
-                <a:spcPts val="0"/>
-              </a:spcAft>
-            </a:pPr>
-            <a:r>
-              <a:rPr sz="950" b="0" i="0">
-                <a:solidFill>
-                  <a:srgbClr val="948FA0"/>
-                </a:solidFill>
-                <a:latin typeface="Calibri"/>
-              </a:rPr>
-              <a:t>Upload any CSV - detection, cleaning, charts, modeling all run live.</a:t>
-            </a:r>
-          </a:p>
-        </p:txBody>
-      </p:sp>
-    </p:spTree>
-  </p:cSld>
-  <p:clrMapOvr>
-    <a:masterClrMapping/>
-  </p:clrMapOvr>
-</p:sld>
-</file>
-
 <file path=ppt/theme/theme1.xml><?xml version="1.0" encoding="utf-8"?>
 <a:theme xmlns:a="http://schemas.openxmlformats.org/drawingml/2006/main" name="Office Theme">
   <a:themeElements>

</xml_diff>